<commit_message>
Update capstone presentation: fix Kaplan -> Catlin (professor's name)
Same file serves both the inline viewer and the download link, so
this one swap fixes both.

Co-Authored-By: Claude Sonnet 5 <noreply@anthropic.com>
</commit_message>
<xml_diff>
--- a/capstone/Capstone-Presentation-Felder.pptx
+++ b/capstone/Capstone-Presentation-Felder.pptx
@@ -4,6 +4,9 @@
   <p:sldMasterIdLst>
     <p:sldMasterId id="2147483648" r:id="rId1"/>
   </p:sldMasterIdLst>
+  <p:notesMasterIdLst>
+    <p:notesMasterId r:id="rId22"/>
+  </p:notesMasterIdLst>
   <p:sldIdLst>
     <p:sldId id="256" r:id="rId2"/>
     <p:sldId id="257" r:id="rId3"/>
@@ -26,9 +29,6 @@
     <p:sldId id="274" r:id="rId20"/>
     <p:sldId id="275" r:id="rId21"/>
   </p:sldIdLst>
-  <p:notesMasterIdLst>
-    <p:notesMasterId r:id="rId22"/>
-  </p:notesMasterIdLst>
   <p:sldSz cx="12192000" cy="6858000"/>
   <p:notesSz cx="6858000" cy="12192000"/>
   <p:defaultTextStyle>
@@ -123,6 +123,11 @@
       </a:defRPr>
     </a:lvl9pPr>
   </p:defaultTextStyle>
+  <p:extLst>
+    <p:ext uri="{EFAFB233-063F-42B5-8137-9DF3F51BA10A}">
+      <p15:sldGuideLst xmlns:p15="http://schemas.microsoft.com/office/powerpoint/2012/main"/>
+    </p:ext>
+  </p:extLst>
 </p:presentation>
 </file>
 
@@ -148,234 +153,10 @@
           <a:chExt cx="0" cy="0"/>
         </a:xfrm>
       </p:grpSpPr>
-      <p:sp>
-        <p:nvSpPr>
-          <p:cNvPr id="2" name="Header Placeholder 1"/>
-          <p:cNvSpPr>
-            <a:spLocks noGrp="1"/>
-          </p:cNvSpPr>
-          <p:nvPr>
-            <p:ph type="hdr" sz="quarter"/>
-          </p:nvPr>
-        </p:nvSpPr>
-        <p:spPr>
-          <a:xfrm>
-            <a:off x="0" y="0"/>
-            <a:ext cx="2971800" cy="458788"/>
-          </a:xfrm>
-          <a:prstGeom prst="rect">
-            <a:avLst/>
-          </a:prstGeom>
-        </p:spPr>
-        <p:txBody>
-          <a:bodyPr vert="horz" lIns="91440" tIns="45720" rIns="91440" bIns="45720" rtlCol="0"/>
-          <a:lstStyle>
-            <a:lvl1pPr algn="l">
-              <a:defRPr sz="1200"/>
-            </a:lvl1pPr>
-          </a:lstStyle>
-          <a:p>
-            <a:endParaRPr lang="en-US"/>
-          </a:p>
-        </p:txBody>
-      </p:sp>
-      <p:sp>
-        <p:nvSpPr>
-          <p:cNvPr id="3" name="Date Placeholder 2"/>
-          <p:cNvSpPr>
-            <a:spLocks noGrp="1"/>
-          </p:cNvSpPr>
-          <p:nvPr>
-            <p:ph type="dt" idx="1"/>
-          </p:nvPr>
-        </p:nvSpPr>
-        <p:spPr>
-          <a:xfrm>
-            <a:off x="3884613" y="0"/>
-            <a:ext cx="2971800" cy="458788"/>
-          </a:xfrm>
-          <a:prstGeom prst="rect">
-            <a:avLst/>
-          </a:prstGeom>
-        </p:spPr>
-        <p:txBody>
-          <a:bodyPr vert="horz" lIns="91440" tIns="45720" rIns="91440" bIns="45720" rtlCol="0"/>
-          <a:lstStyle>
-            <a:lvl1pPr algn="r">
-              <a:defRPr sz="1200"/>
-            </a:lvl1pPr>
-          </a:lstStyle>
-          <a:p>
-            <a:fld id="{5282F153-3F37-0F45-9E97-73ACFA13230C}" type="datetimeFigureOut">
-              <a:rPr lang="en-US"/>
-              <a:t>7/23/19</a:t>
-            </a:fld>
-            <a:endParaRPr lang="en-US"/>
-          </a:p>
-        </p:txBody>
-      </p:sp>
-      <p:sp>
-        <p:nvSpPr>
-          <p:cNvPr id="4" name="Slide Image Placeholder 3"/>
-          <p:cNvSpPr>
-            <a:spLocks noGrp="1" noRot="1" noChangeAspect="1"/>
-          </p:cNvSpPr>
-          <p:nvPr>
-            <p:ph type="sldImg" idx="2"/>
-          </p:nvPr>
-        </p:nvSpPr>
-        <p:spPr>
-          <a:xfrm>
-            <a:off x="685800" y="1143000"/>
-            <a:ext cx="5486400" cy="3086100"/>
-          </a:xfrm>
-          <a:prstGeom prst="rect">
-            <a:avLst/>
-          </a:prstGeom>
-          <a:noFill/>
-          <a:ln w="12700">
-            <a:solidFill>
-              <a:prstClr val="black"/>
-            </a:solidFill>
-          </a:ln>
-        </p:spPr>
-        <p:txBody>
-          <a:bodyPr vert="horz" lIns="91440" tIns="45720" rIns="91440" bIns="45720" rtlCol="0" anchor="ctr"/>
-          <a:lstStyle/>
-          <a:p>
-            <a:endParaRPr lang="en-US"/>
-          </a:p>
-        </p:txBody>
-      </p:sp>
-      <p:sp>
-        <p:nvSpPr>
-          <p:cNvPr id="5" name="Notes Placeholder 4"/>
-          <p:cNvSpPr>
-            <a:spLocks noGrp="1"/>
-          </p:cNvSpPr>
-          <p:nvPr>
-            <p:ph type="body" sz="quarter" idx="3"/>
-          </p:nvPr>
-        </p:nvSpPr>
-        <p:spPr>
-          <a:xfrm>
-            <a:off x="685800" y="4400550"/>
-            <a:ext cx="5486400" cy="3600450"/>
-          </a:xfrm>
-          <a:prstGeom prst="rect">
-            <a:avLst/>
-          </a:prstGeom>
-        </p:spPr>
-        <p:txBody>
-          <a:bodyPr vert="horz" lIns="91440" tIns="45720" rIns="91440" bIns="45720" rtlCol="0"/>
-          <a:lstStyle/>
-          <a:p>
-            <a:pPr lvl="0"/>
-            <a:r>
-              <a:rPr lang="en-US"/>
-              <a:t>Click to edit Master text styles</a:t>
-            </a:r>
-          </a:p>
-          <a:p>
-            <a:pPr lvl="1"/>
-            <a:r>
-              <a:rPr lang="en-US"/>
-              <a:t>Second level</a:t>
-            </a:r>
-          </a:p>
-          <a:p>
-            <a:pPr lvl="2"/>
-            <a:r>
-              <a:rPr lang="en-US"/>
-              <a:t>Third level</a:t>
-            </a:r>
-          </a:p>
-          <a:p>
-            <a:pPr lvl="3"/>
-            <a:r>
-              <a:rPr lang="en-US"/>
-              <a:t>Fourth level</a:t>
-            </a:r>
-          </a:p>
-          <a:p>
-            <a:pPr lvl="4"/>
-            <a:r>
-              <a:rPr lang="en-US"/>
-              <a:t>Fifth level</a:t>
-            </a:r>
-          </a:p>
-        </p:txBody>
-      </p:sp>
-      <p:sp>
-        <p:nvSpPr>
-          <p:cNvPr id="6" name="Footer Placeholder 5"/>
-          <p:cNvSpPr>
-            <a:spLocks noGrp="1"/>
-          </p:cNvSpPr>
-          <p:nvPr>
-            <p:ph type="ftr" sz="quarter" idx="4"/>
-          </p:nvPr>
-        </p:nvSpPr>
-        <p:spPr>
-          <a:xfrm>
-            <a:off x="0" y="8685213"/>
-            <a:ext cx="2971800" cy="458787"/>
-          </a:xfrm>
-          <a:prstGeom prst="rect">
-            <a:avLst/>
-          </a:prstGeom>
-        </p:spPr>
-        <p:txBody>
-          <a:bodyPr vert="horz" lIns="91440" tIns="45720" rIns="91440" bIns="45720" rtlCol="0" anchor="b"/>
-          <a:lstStyle>
-            <a:lvl1pPr algn="l">
-              <a:defRPr sz="1200"/>
-            </a:lvl1pPr>
-          </a:lstStyle>
-          <a:p>
-            <a:endParaRPr lang="en-US"/>
-          </a:p>
-        </p:txBody>
-      </p:sp>
-      <p:sp>
-        <p:nvSpPr>
-          <p:cNvPr id="7" name="Slide Number Placeholder 6"/>
-          <p:cNvSpPr>
-            <a:spLocks noGrp="1"/>
-          </p:cNvSpPr>
-          <p:nvPr>
-            <p:ph type="sldNum" sz="quarter" idx="5"/>
-          </p:nvPr>
-        </p:nvSpPr>
-        <p:spPr>
-          <a:xfrm>
-            <a:off x="3884613" y="8685213"/>
-            <a:ext cx="2971800" cy="458787"/>
-          </a:xfrm>
-          <a:prstGeom prst="rect">
-            <a:avLst/>
-          </a:prstGeom>
-        </p:spPr>
-        <p:txBody>
-          <a:bodyPr vert="horz" lIns="91440" tIns="45720" rIns="91440" bIns="45720" rtlCol="0" anchor="b"/>
-          <a:lstStyle>
-            <a:lvl1pPr algn="r">
-              <a:defRPr sz="1200"/>
-            </a:lvl1pPr>
-          </a:lstStyle>
-          <a:p>
-            <a:fld id="{CE5E9CC1-C706-0F49-92D6-E571CC5EEA8F}" type="slidenum">
-              <a:rPr lang="en-US"/>
-              <a:t>‹#›</a:t>
-            </a:fld>
-            <a:endParaRPr lang="en-US"/>
-          </a:p>
-        </p:txBody>
-      </p:sp>
     </p:spTree>
     <p:extLst>
       <p:ext uri="{BB962C8B-B14F-4D97-AF65-F5344CB8AC3E}">
-        <p14:creationId xmlns:p14="http://schemas.microsoft.com/office/powerpoint/2010/main" val="1024086991"/>
+        <p14:creationId xmlns:p14="http://schemas.microsoft.com/office/powerpoint/2010/main" val="1469124916"/>
       </p:ext>
     </p:extLst>
   </p:cSld>
@@ -523,7 +304,6 @@
               <a:rPr lang="en-US" dirty="0"/>
               <a:t>Introduce myself, the program, the semester, and the focus on agentic AI under Prof. Catlin.</a:t>
             </a:r>
-            <a:endParaRPr lang="en-US" dirty="0"/>
           </a:p>
         </p:txBody>
       </p:sp>
@@ -611,7 +391,6 @@
               <a:rPr lang="en-US" dirty="0"/>
               <a:t>This is the central lesson of the dashboard half of the capstone.</a:t>
             </a:r>
-            <a:endParaRPr lang="en-US" dirty="0"/>
           </a:p>
         </p:txBody>
       </p:sp>
@@ -699,7 +478,6 @@
               <a:rPr lang="en-US" dirty="0"/>
               <a:t>Explain the split: CLAUDE.md is written for the model, the PRD is written for a person.</a:t>
             </a:r>
-            <a:endParaRPr lang="en-US" dirty="0"/>
           </a:p>
         </p:txBody>
       </p:sp>
@@ -787,7 +565,6 @@
               <a:rPr lang="en-US" dirty="0"/>
               <a:t>Transition slide into the agentic AI half of the talk.</a:t>
             </a:r>
-            <a:endParaRPr lang="en-US" dirty="0"/>
           </a:p>
         </p:txBody>
       </p:sp>
@@ -875,7 +652,6 @@
               <a:rPr lang="en-US" dirty="0"/>
               <a:t>Mention the /context command and that I checked it as I worked.</a:t>
             </a:r>
-            <a:endParaRPr lang="en-US" dirty="0"/>
           </a:p>
         </p:txBody>
       </p:sp>
@@ -963,7 +739,6 @@
               <a:rPr lang="en-US" dirty="0"/>
               <a:t>Use the completions dashboard as the concrete example of slicing.</a:t>
             </a:r>
-            <a:endParaRPr lang="en-US" dirty="0"/>
           </a:p>
         </p:txBody>
       </p:sp>
@@ -1051,7 +826,6 @@
               <a:rPr lang="en-US" dirty="0"/>
               <a:t>Note that this skill is downloadable into your own Claude Code environment.</a:t>
             </a:r>
-            <a:endParaRPr lang="en-US" dirty="0"/>
           </a:p>
         </p:txBody>
       </p:sp>
@@ -1139,7 +913,6 @@
               <a:rPr lang="en-US" dirty="0"/>
               <a:t>Be honest that only two of the five steps were used directly, and why that was reasonable.</a:t>
             </a:r>
-            <a:endParaRPr lang="en-US" dirty="0"/>
           </a:p>
         </p:txBody>
       </p:sp>
@@ -1227,7 +1000,6 @@
               <a:rPr lang="en-US" dirty="0"/>
               <a:t>Give the accounting and healthcare marketing examples out loud.</a:t>
             </a:r>
-            <a:endParaRPr lang="en-US" dirty="0"/>
           </a:p>
         </p:txBody>
       </p:sp>
@@ -1315,7 +1087,6 @@
               <a:rPr lang="en-US" dirty="0"/>
               <a:t>Be straightforward that JSON would have done the job; Postgres was a deliberate learning choice.</a:t>
             </a:r>
-            <a:endParaRPr lang="en-US" dirty="0"/>
           </a:p>
         </p:txBody>
       </p:sp>
@@ -1403,7 +1174,6 @@
               <a:rPr lang="en-US" dirty="0"/>
               <a:t>Add the personal note: I think the React builds look a little better, though not dramatically.</a:t>
             </a:r>
-            <a:endParaRPr lang="en-US" dirty="0"/>
           </a:p>
         </p:txBody>
       </p:sp>
@@ -1491,7 +1261,6 @@
               <a:rPr lang="en-US" dirty="0"/>
               <a:t>Frame the two halves of the capstone: the dashboards, and the agentic AI method behind them.</a:t>
             </a:r>
-            <a:endParaRPr lang="en-US" dirty="0"/>
           </a:p>
         </p:txBody>
       </p:sp>
@@ -1579,7 +1348,6 @@
               <a:rPr lang="en-US" dirty="0"/>
               <a:t>Close with thanks to Prof. Catlin, Dr. Kaplan, and the program.</a:t>
             </a:r>
-            <a:endParaRPr lang="en-US" dirty="0"/>
           </a:p>
         </p:txBody>
       </p:sp>
@@ -1667,7 +1435,6 @@
               <a:rPr lang="en-US" dirty="0"/>
               <a:t>Be clear that this is a starting point and a resource, not an official deliverable.</a:t>
             </a:r>
-            <a:endParaRPr lang="en-US" dirty="0"/>
           </a:p>
         </p:txBody>
       </p:sp>
@@ -1755,7 +1522,6 @@
               <a:rPr lang="en-US" dirty="0"/>
               <a:t>Point people to the site. Mention the capstone tab and that READMEs are the first stop.</a:t>
             </a:r>
-            <a:endParaRPr lang="en-US" dirty="0"/>
           </a:p>
         </p:txBody>
       </p:sp>
@@ -1843,7 +1609,6 @@
               <a:rPr lang="en-US" dirty="0"/>
               <a:t>Quick map of all four before walking through them one at a time.</a:t>
             </a:r>
-            <a:endParaRPr lang="en-US" dirty="0"/>
           </a:p>
         </p:txBody>
       </p:sp>
@@ -1931,7 +1696,6 @@
               <a:rPr lang="en-US" dirty="0"/>
               <a:t>Explain that this came first even though I present it here, and that it was synthetic data.</a:t>
             </a:r>
-            <a:endParaRPr lang="en-US" dirty="0"/>
           </a:p>
         </p:txBody>
       </p:sp>
@@ -2019,7 +1783,6 @@
               <a:rPr lang="en-US" dirty="0"/>
               <a:t>Walk through the CIP toggle and the year range. Mention the five peer institutions.</a:t>
             </a:r>
-            <a:endParaRPr lang="en-US" dirty="0"/>
           </a:p>
         </p:txBody>
       </p:sp>
@@ -2107,7 +1870,6 @@
               <a:rPr lang="en-US" dirty="0"/>
               <a:t>Contrast this with the tuition dashboard: management view versus student view.</a:t>
             </a:r>
-            <a:endParaRPr lang="en-US" dirty="0"/>
           </a:p>
         </p:txBody>
       </p:sp>
@@ -2195,7 +1957,6 @@
               <a:rPr lang="en-US" dirty="0"/>
               <a:t>Explain the student-perspective framing and why this one is repo-only.</a:t>
             </a:r>
-            <a:endParaRPr lang="en-US" dirty="0"/>
           </a:p>
         </p:txBody>
       </p:sp>
@@ -2268,6 +2029,11 @@
 <file path=ppt/slideMasters/slideMaster1.xml><?xml version="1.0" encoding="utf-8"?>
 <p:sldMaster xmlns:a="http://schemas.openxmlformats.org/drawingml/2006/main" xmlns:r="http://schemas.openxmlformats.org/officeDocument/2006/relationships" xmlns:p="http://schemas.openxmlformats.org/presentationml/2006/main">
   <p:cSld>
+    <p:bg>
+      <p:bgRef idx="1001">
+        <a:schemeClr val="bg1"/>
+      </p:bgRef>
+    </p:bg>
     <p:spTree>
       <p:nvGrpSpPr>
         <p:cNvPr id="1" name=""/>
@@ -2550,6 +2316,7 @@
         <a:solidFill>
           <a:srgbClr val="12294F"/>
         </a:solidFill>
+        <a:effectLst/>
       </p:bgPr>
     </p:bg>
     <p:spTree>
@@ -2587,11 +2354,11 @@
           <a:bodyPr wrap="square" lIns="0" tIns="0" rIns="0" bIns="0" rtlCol="0" anchor="ctr"/>
           <a:lstStyle/>
           <a:p>
-            <a:pPr indent="0" marL="0">
-              <a:buNone/>
-            </a:pPr>
-            <a:r>
-              <a:rPr lang="en-US" sz="1200" b="1" spc="200" kern="0" dirty="0">
+            <a:pPr marL="0" indent="0">
+              <a:buNone/>
+            </a:pPr>
+            <a:r>
+              <a:rPr lang="en-US" sz="1200" b="1" kern="0" spc="200" dirty="0">
                 <a:solidFill>
                   <a:srgbClr val="BFD0E8"/>
                 </a:solidFill>
@@ -2626,7 +2393,7 @@
           <a:bodyPr wrap="square" lIns="0" tIns="0" rIns="0" bIns="0" rtlCol="0" anchor="ctr"/>
           <a:lstStyle/>
           <a:p>
-            <a:pPr indent="0" marL="0">
+            <a:pPr marL="0" indent="0">
               <a:lnSpc>
                 <a:spcPts val="4600"/>
               </a:lnSpc>
@@ -2646,7 +2413,7 @@
             <a:endParaRPr lang="en-US" sz="4200" dirty="0"/>
           </a:p>
           <a:p>
-            <a:pPr indent="0" marL="0">
+            <a:pPr marL="0" indent="0">
               <a:lnSpc>
                 <a:spcPts val="4600"/>
               </a:lnSpc>
@@ -2688,7 +2455,7 @@
           <a:bodyPr wrap="square" lIns="0" tIns="0" rIns="0" bIns="0" rtlCol="0" anchor="ctr"/>
           <a:lstStyle/>
           <a:p>
-            <a:pPr indent="0" marL="0">
+            <a:pPr marL="0" indent="0">
               <a:buNone/>
             </a:pPr>
             <a:r>
@@ -2730,6 +2497,13 @@
             <a:prstDash val="solid"/>
           </a:ln>
         </p:spPr>
+        <p:txBody>
+          <a:bodyPr/>
+          <a:lstStyle/>
+          <a:p>
+            <a:endParaRPr lang="en-US"/>
+          </a:p>
+        </p:txBody>
       </p:sp>
       <p:sp>
         <p:nvSpPr>
@@ -2752,7 +2526,7 @@
           <a:bodyPr wrap="square" lIns="0" tIns="0" rIns="0" bIns="0" rtlCol="0" anchor="ctr"/>
           <a:lstStyle/>
           <a:p>
-            <a:pPr indent="0" marL="0">
+            <a:pPr marL="0" indent="0">
               <a:buNone/>
             </a:pPr>
             <a:r>
@@ -2791,7 +2565,7 @@
           <a:bodyPr wrap="square" lIns="0" tIns="0" rIns="0" bIns="0" rtlCol="0" anchor="ctr"/>
           <a:lstStyle/>
           <a:p>
-            <a:pPr indent="0" marL="0">
+            <a:pPr marL="0" indent="0">
               <a:lnSpc>
                 <a:spcPts val="1900"/>
               </a:lnSpc>
@@ -2811,7 +2585,7 @@
             <a:endParaRPr lang="en-US" sz="1300" dirty="0"/>
           </a:p>
           <a:p>
-            <a:pPr indent="0" marL="0">
+            <a:pPr marL="0" indent="0">
               <a:lnSpc>
                 <a:spcPts val="1900"/>
               </a:lnSpc>
@@ -2853,7 +2627,7 @@
           <a:bodyPr wrap="square" lIns="0" tIns="0" rIns="0" bIns="0" rtlCol="0" anchor="ctr"/>
           <a:lstStyle/>
           <a:p>
-            <a:pPr indent="0" marL="0">
+            <a:pPr marL="0" indent="0">
               <a:buNone/>
             </a:pPr>
             <a:r>
@@ -2864,7 +2638,7 @@
                 <a:latin typeface="Courier New" pitchFamily="34" charset="0"/>
                 <a:ea typeface="Courier New" pitchFamily="34" charset="-122"/>
                 <a:cs typeface="Courier New" pitchFamily="34" charset="-120"/>
-                <a:hlinkClick r:id="rId1" invalidUrl="" action="" tgtFrame="" tooltip="" history="1" highlightClick="0" endSnd="0">
+                <a:hlinkClick r:id="rId3">
                   <a:extLst>
                     <a:ext uri="{A12FA001-AC4F-418D-AE19-62706E023703}">
                       <ahyp:hlinkClr xmlns:ahyp="http://schemas.microsoft.com/office/drawing/2018/hyperlinkcolor" val="tx"/>
@@ -2924,7 +2698,7 @@
           <a:bodyPr wrap="square" lIns="0" tIns="0" rIns="0" bIns="0" rtlCol="0" anchor="ctr"/>
           <a:lstStyle/>
           <a:p>
-            <a:pPr indent="0" marL="0">
+            <a:pPr marL="0" indent="0">
               <a:buNone/>
             </a:pPr>
             <a:r>
@@ -2963,7 +2737,7 @@
           <a:bodyPr wrap="square" lIns="0" tIns="0" rIns="0" bIns="0" rtlCol="0" anchor="ctr"/>
           <a:lstStyle/>
           <a:p>
-            <a:pPr indent="0" marL="0">
+            <a:pPr marL="0" indent="0">
               <a:buNone/>
             </a:pPr>
             <a:r>
@@ -2975,7 +2749,7 @@
                 <a:ea typeface="Calibri" pitchFamily="34" charset="-122"/>
                 <a:cs typeface="Calibri" pitchFamily="34" charset="-120"/>
               </a:rPr>
-              <a:t>The lesson Dr. Kaplan pushed me toward, and the one that changed the project</a:t>
+              <a:t>The lesson Dr. Catlin pushed me toward, and the one that changed the project</a:t>
             </a:r>
             <a:endParaRPr lang="en-US" sz="1500" dirty="0"/>
           </a:p>
@@ -3007,13 +2781,20 @@
             <a:prstDash val="solid"/>
           </a:ln>
           <a:effectLst>
-            <a:outerShdw sx="100000" sy="100000" kx="0" ky="0" algn="bl" rotWithShape="0" blurRad="127000" dist="25400" dir="5400000">
+            <a:outerShdw blurRad="127000" dist="25400" dir="5400000" algn="bl" rotWithShape="0">
               <a:srgbClr val="9AAAC4">
                 <a:alpha val="30000"/>
               </a:srgbClr>
             </a:outerShdw>
           </a:effectLst>
         </p:spPr>
+        <p:txBody>
+          <a:bodyPr/>
+          <a:lstStyle/>
+          <a:p>
+            <a:endParaRPr lang="en-US"/>
+          </a:p>
+        </p:txBody>
       </p:sp>
       <p:sp>
         <p:nvSpPr>
@@ -3036,11 +2817,11 @@
           <a:bodyPr wrap="square" lIns="0" tIns="0" rIns="0" bIns="0" rtlCol="0" anchor="ctr"/>
           <a:lstStyle/>
           <a:p>
-            <a:pPr indent="0" marL="0">
-              <a:buNone/>
-            </a:pPr>
-            <a:r>
-              <a:rPr lang="en-US" sz="1100" b="1" spc="150" kern="0" dirty="0">
+            <a:pPr marL="0" indent="0">
+              <a:buNone/>
+            </a:pPr>
+            <a:r>
+              <a:rPr lang="en-US" sz="1100" b="1" kern="0" spc="150" dirty="0">
                 <a:solidFill>
                   <a:srgbClr val="C07A22"/>
                 </a:solidFill>
@@ -3075,7 +2856,7 @@
           <a:bodyPr wrap="square" lIns="0" tIns="0" rIns="0" bIns="0" rtlCol="0" anchor="ctr"/>
           <a:lstStyle/>
           <a:p>
-            <a:pPr indent="0" marL="0">
+            <a:pPr marL="0" indent="0">
               <a:buNone/>
             </a:pPr>
             <a:r>
@@ -3114,7 +2895,7 @@
           <a:bodyPr wrap="square" lIns="0" tIns="0" rIns="0" bIns="0" rtlCol="0" anchor="t"/>
           <a:lstStyle/>
           <a:p>
-            <a:pPr indent="0" marL="0">
+            <a:pPr marL="0" indent="0">
               <a:buNone/>
             </a:pPr>
             <a:r>
@@ -3158,13 +2939,20 @@
             <a:prstDash val="solid"/>
           </a:ln>
           <a:effectLst>
-            <a:outerShdw sx="100000" sy="100000" kx="0" ky="0" algn="bl" rotWithShape="0" blurRad="127000" dist="25400" dir="5400000">
+            <a:outerShdw blurRad="127000" dist="25400" dir="5400000" algn="bl" rotWithShape="0">
               <a:srgbClr val="9AAAC4">
                 <a:alpha val="30000"/>
               </a:srgbClr>
             </a:outerShdw>
           </a:effectLst>
         </p:spPr>
+        <p:txBody>
+          <a:bodyPr/>
+          <a:lstStyle/>
+          <a:p>
+            <a:endParaRPr lang="en-US"/>
+          </a:p>
+        </p:txBody>
       </p:sp>
       <p:sp>
         <p:nvSpPr>
@@ -3187,11 +2975,11 @@
           <a:bodyPr wrap="square" lIns="0" tIns="0" rIns="0" bIns="0" rtlCol="0" anchor="ctr"/>
           <a:lstStyle/>
           <a:p>
-            <a:pPr indent="0" marL="0">
-              <a:buNone/>
-            </a:pPr>
-            <a:r>
-              <a:rPr lang="en-US" sz="1100" b="1" spc="150" kern="0" dirty="0">
+            <a:pPr marL="0" indent="0">
+              <a:buNone/>
+            </a:pPr>
+            <a:r>
+              <a:rPr lang="en-US" sz="1100" b="1" kern="0" spc="150" dirty="0">
                 <a:solidFill>
                   <a:srgbClr val="C07A22"/>
                 </a:solidFill>
@@ -3226,7 +3014,7 @@
           <a:bodyPr wrap="square" lIns="0" tIns="0" rIns="0" bIns="0" rtlCol="0" anchor="ctr"/>
           <a:lstStyle/>
           <a:p>
-            <a:pPr indent="0" marL="0">
+            <a:pPr marL="0" indent="0">
               <a:buNone/>
             </a:pPr>
             <a:r>
@@ -3265,7 +3053,7 @@
           <a:bodyPr wrap="square" lIns="0" tIns="0" rIns="0" bIns="0" rtlCol="0" anchor="t"/>
           <a:lstStyle/>
           <a:p>
-            <a:pPr indent="0" marL="0">
+            <a:pPr marL="0" indent="0">
               <a:buNone/>
             </a:pPr>
             <a:r>
@@ -3309,6 +3097,13 @@
             <a:prstDash val="solid"/>
           </a:ln>
         </p:spPr>
+        <p:txBody>
+          <a:bodyPr/>
+          <a:lstStyle/>
+          <a:p>
+            <a:endParaRPr lang="en-US"/>
+          </a:p>
+        </p:txBody>
       </p:sp>
       <p:sp>
         <p:nvSpPr>
@@ -3331,7 +3126,7 @@
           <a:bodyPr wrap="square" lIns="0" tIns="0" rIns="0" bIns="0" rtlCol="0" anchor="ctr"/>
           <a:lstStyle/>
           <a:p>
-            <a:pPr indent="0" marL="0">
+            <a:pPr marL="0" indent="0">
               <a:buNone/>
             </a:pPr>
             <a:r>
@@ -3370,7 +3165,7 @@
           <a:bodyPr wrap="square" lIns="0" tIns="0" rIns="0" bIns="0" rtlCol="0" anchor="ctr"/>
           <a:lstStyle/>
           <a:p>
-            <a:pPr indent="0" marL="0">
+            <a:pPr marL="0" indent="0">
               <a:buNone/>
             </a:pPr>
             <a:r>
@@ -3434,7 +3229,7 @@
           <a:bodyPr wrap="square" lIns="0" tIns="0" rIns="0" bIns="0" rtlCol="0" anchor="ctr"/>
           <a:lstStyle/>
           <a:p>
-            <a:pPr indent="0" marL="0">
+            <a:pPr marL="0" indent="0">
               <a:buNone/>
             </a:pPr>
             <a:r>
@@ -3473,7 +3268,7 @@
           <a:bodyPr wrap="square" lIns="0" tIns="0" rIns="0" bIns="0" rtlCol="0" anchor="ctr"/>
           <a:lstStyle/>
           <a:p>
-            <a:pPr indent="0" marL="0">
+            <a:pPr marL="0" indent="0">
               <a:buNone/>
             </a:pPr>
             <a:r>
@@ -3517,13 +3312,20 @@
             <a:prstDash val="solid"/>
           </a:ln>
           <a:effectLst>
-            <a:outerShdw sx="100000" sy="100000" kx="0" ky="0" algn="bl" rotWithShape="0" blurRad="127000" dist="25400" dir="5400000">
+            <a:outerShdw blurRad="127000" dist="25400" dir="5400000" algn="bl" rotWithShape="0">
               <a:srgbClr val="9AAAC4">
                 <a:alpha val="30000"/>
               </a:srgbClr>
             </a:outerShdw>
           </a:effectLst>
         </p:spPr>
+        <p:txBody>
+          <a:bodyPr/>
+          <a:lstStyle/>
+          <a:p>
+            <a:endParaRPr lang="en-US"/>
+          </a:p>
+        </p:txBody>
       </p:sp>
       <p:sp>
         <p:nvSpPr>
@@ -3546,7 +3348,7 @@
           <a:bodyPr wrap="square" lIns="0" tIns="0" rIns="0" bIns="0" rtlCol="0" anchor="ctr"/>
           <a:lstStyle/>
           <a:p>
-            <a:pPr indent="0" marL="0">
+            <a:pPr marL="0" indent="0">
               <a:buNone/>
             </a:pPr>
             <a:r>
@@ -3585,11 +3387,11 @@
           <a:bodyPr wrap="square" lIns="0" tIns="0" rIns="0" bIns="0" rtlCol="0" anchor="ctr"/>
           <a:lstStyle/>
           <a:p>
-            <a:pPr indent="0" marL="0">
-              <a:buNone/>
-            </a:pPr>
-            <a:r>
-              <a:rPr lang="en-US" sz="1050" b="1" spc="150" kern="0" dirty="0">
+            <a:pPr marL="0" indent="0">
+              <a:buNone/>
+            </a:pPr>
+            <a:r>
+              <a:rPr lang="en-US" sz="1050" b="1" kern="0" spc="150" dirty="0">
                 <a:solidFill>
                   <a:srgbClr val="C07A22"/>
                 </a:solidFill>
@@ -3624,7 +3426,7 @@
           <a:bodyPr wrap="square" lIns="0" tIns="0" rIns="0" bIns="0" rtlCol="0" anchor="t"/>
           <a:lstStyle/>
           <a:p>
-            <a:pPr indent="0" marL="0">
+            <a:pPr marL="0" indent="0">
               <a:buNone/>
             </a:pPr>
             <a:r>
@@ -3668,13 +3470,20 @@
             <a:prstDash val="solid"/>
           </a:ln>
           <a:effectLst>
-            <a:outerShdw sx="100000" sy="100000" kx="0" ky="0" algn="bl" rotWithShape="0" blurRad="127000" dist="25400" dir="5400000">
+            <a:outerShdw blurRad="127000" dist="25400" dir="5400000" algn="bl" rotWithShape="0">
               <a:srgbClr val="9AAAC4">
                 <a:alpha val="30000"/>
               </a:srgbClr>
             </a:outerShdw>
           </a:effectLst>
         </p:spPr>
+        <p:txBody>
+          <a:bodyPr/>
+          <a:lstStyle/>
+          <a:p>
+            <a:endParaRPr lang="en-US"/>
+          </a:p>
+        </p:txBody>
       </p:sp>
       <p:sp>
         <p:nvSpPr>
@@ -3697,7 +3506,7 @@
           <a:bodyPr wrap="square" lIns="0" tIns="0" rIns="0" bIns="0" rtlCol="0" anchor="ctr"/>
           <a:lstStyle/>
           <a:p>
-            <a:pPr indent="0" marL="0">
+            <a:pPr marL="0" indent="0">
               <a:buNone/>
             </a:pPr>
             <a:r>
@@ -3736,11 +3545,11 @@
           <a:bodyPr wrap="square" lIns="0" tIns="0" rIns="0" bIns="0" rtlCol="0" anchor="ctr"/>
           <a:lstStyle/>
           <a:p>
-            <a:pPr indent="0" marL="0">
-              <a:buNone/>
-            </a:pPr>
-            <a:r>
-              <a:rPr lang="en-US" sz="1050" b="1" spc="150" kern="0" dirty="0">
+            <a:pPr marL="0" indent="0">
+              <a:buNone/>
+            </a:pPr>
+            <a:r>
+              <a:rPr lang="en-US" sz="1050" b="1" kern="0" spc="150" dirty="0">
                 <a:solidFill>
                   <a:srgbClr val="C07A22"/>
                 </a:solidFill>
@@ -3775,7 +3584,7 @@
           <a:bodyPr wrap="square" lIns="0" tIns="0" rIns="0" bIns="0" rtlCol="0" anchor="t"/>
           <a:lstStyle/>
           <a:p>
-            <a:pPr indent="0" marL="0">
+            <a:pPr marL="0" indent="0">
               <a:buNone/>
             </a:pPr>
             <a:r>
@@ -3819,13 +3628,20 @@
             <a:prstDash val="solid"/>
           </a:ln>
           <a:effectLst>
-            <a:outerShdw sx="100000" sy="100000" kx="0" ky="0" algn="bl" rotWithShape="0" blurRad="127000" dist="25400" dir="5400000">
+            <a:outerShdw blurRad="127000" dist="25400" dir="5400000" algn="bl" rotWithShape="0">
               <a:srgbClr val="9AAAC4">
                 <a:alpha val="30000"/>
               </a:srgbClr>
             </a:outerShdw>
           </a:effectLst>
         </p:spPr>
+        <p:txBody>
+          <a:bodyPr/>
+          <a:lstStyle/>
+          <a:p>
+            <a:endParaRPr lang="en-US"/>
+          </a:p>
+        </p:txBody>
       </p:sp>
       <p:sp>
         <p:nvSpPr>
@@ -3848,7 +3664,7 @@
           <a:bodyPr wrap="square" lIns="0" tIns="0" rIns="0" bIns="0" rtlCol="0" anchor="ctr"/>
           <a:lstStyle/>
           <a:p>
-            <a:pPr indent="0" marL="0">
+            <a:pPr marL="0" indent="0">
               <a:buNone/>
             </a:pPr>
             <a:r>
@@ -3887,11 +3703,11 @@
           <a:bodyPr wrap="square" lIns="0" tIns="0" rIns="0" bIns="0" rtlCol="0" anchor="ctr"/>
           <a:lstStyle/>
           <a:p>
-            <a:pPr indent="0" marL="0">
-              <a:buNone/>
-            </a:pPr>
-            <a:r>
-              <a:rPr lang="en-US" sz="1050" b="1" spc="150" kern="0" dirty="0">
+            <a:pPr marL="0" indent="0">
+              <a:buNone/>
+            </a:pPr>
+            <a:r>
+              <a:rPr lang="en-US" sz="1050" b="1" kern="0" spc="150" dirty="0">
                 <a:solidFill>
                   <a:srgbClr val="C07A22"/>
                 </a:solidFill>
@@ -3926,7 +3742,7 @@
           <a:bodyPr wrap="square" lIns="0" tIns="0" rIns="0" bIns="0" rtlCol="0" anchor="t"/>
           <a:lstStyle/>
           <a:p>
-            <a:pPr indent="0" marL="0">
+            <a:pPr marL="0" indent="0">
               <a:buNone/>
             </a:pPr>
             <a:r>
@@ -3960,6 +3776,7 @@
         <a:solidFill>
           <a:srgbClr val="12294F"/>
         </a:solidFill>
+        <a:effectLst/>
       </p:bgPr>
     </p:bg>
     <p:spTree>
@@ -3997,11 +3814,11 @@
           <a:bodyPr wrap="square" lIns="0" tIns="0" rIns="0" bIns="0" rtlCol="0" anchor="ctr"/>
           <a:lstStyle/>
           <a:p>
-            <a:pPr indent="0" marL="0">
-              <a:buNone/>
-            </a:pPr>
-            <a:r>
-              <a:rPr lang="en-US" sz="1300" b="1" spc="300" kern="0" dirty="0">
+            <a:pPr marL="0" indent="0">
+              <a:buNone/>
+            </a:pPr>
+            <a:r>
+              <a:rPr lang="en-US" sz="1300" b="1" kern="0" spc="300" dirty="0">
                 <a:solidFill>
                   <a:srgbClr val="BFD0E8"/>
                 </a:solidFill>
@@ -4036,7 +3853,7 @@
           <a:bodyPr wrap="square" lIns="0" tIns="0" rIns="0" bIns="0" rtlCol="0" anchor="ctr"/>
           <a:lstStyle/>
           <a:p>
-            <a:pPr indent="0" marL="0">
+            <a:pPr marL="0" indent="0">
               <a:buNone/>
             </a:pPr>
             <a:r>
@@ -4075,7 +3892,7 @@
           <a:bodyPr wrap="square" lIns="0" tIns="0" rIns="0" bIns="0" rtlCol="0" anchor="ctr"/>
           <a:lstStyle/>
           <a:p>
-            <a:pPr indent="0" marL="0">
+            <a:pPr marL="0" indent="0">
               <a:buNone/>
             </a:pPr>
             <a:r>
@@ -4139,7 +3956,7 @@
           <a:bodyPr wrap="square" lIns="0" tIns="0" rIns="0" bIns="0" rtlCol="0" anchor="ctr"/>
           <a:lstStyle/>
           <a:p>
-            <a:pPr indent="0" marL="0">
+            <a:pPr marL="0" indent="0">
               <a:buNone/>
             </a:pPr>
             <a:r>
@@ -4178,7 +3995,7 @@
           <a:bodyPr wrap="square" lIns="0" tIns="0" rIns="0" bIns="0" rtlCol="0" anchor="ctr"/>
           <a:lstStyle/>
           <a:p>
-            <a:pPr indent="0" marL="0">
+            <a:pPr marL="0" indent="0">
               <a:buNone/>
             </a:pPr>
             <a:r>
@@ -4222,13 +4039,20 @@
             <a:prstDash val="solid"/>
           </a:ln>
           <a:effectLst>
-            <a:outerShdw sx="100000" sy="100000" kx="0" ky="0" algn="bl" rotWithShape="0" blurRad="127000" dist="25400" dir="5400000">
+            <a:outerShdw blurRad="127000" dist="25400" dir="5400000" algn="bl" rotWithShape="0">
               <a:srgbClr val="9AAAC4">
                 <a:alpha val="30000"/>
               </a:srgbClr>
             </a:outerShdw>
           </a:effectLst>
         </p:spPr>
+        <p:txBody>
+          <a:bodyPr/>
+          <a:lstStyle/>
+          <a:p>
+            <a:endParaRPr lang="en-US"/>
+          </a:p>
+        </p:txBody>
       </p:sp>
       <p:sp>
         <p:nvSpPr>
@@ -4251,7 +4075,7 @@
           <a:bodyPr wrap="square" lIns="0" tIns="0" rIns="0" bIns="0" rtlCol="0" anchor="ctr"/>
           <a:lstStyle/>
           <a:p>
-            <a:pPr algn="ctr" indent="0" marL="0">
+            <a:pPr marL="0" indent="0" algn="ctr">
               <a:buNone/>
             </a:pPr>
             <a:r>
@@ -4290,7 +4114,7 @@
           <a:bodyPr wrap="square" lIns="0" tIns="0" rIns="0" bIns="0" rtlCol="0" anchor="ctr"/>
           <a:lstStyle/>
           <a:p>
-            <a:pPr algn="ctr" indent="0" marL="0">
+            <a:pPr marL="0" indent="0" algn="ctr">
               <a:lnSpc>
                 <a:spcPts val="2000"/>
               </a:lnSpc>
@@ -4310,7 +4134,7 @@
             <a:endParaRPr lang="en-US" sz="1400" dirty="0"/>
           </a:p>
           <a:p>
-            <a:pPr algn="ctr" indent="0" marL="0">
+            <a:pPr marL="0" indent="0" algn="ctr">
               <a:lnSpc>
                 <a:spcPts val="2000"/>
               </a:lnSpc>
@@ -4462,7 +4286,7 @@
           <a:bodyPr wrap="square" lIns="0" tIns="0" rIns="0" bIns="0" rtlCol="0" anchor="ctr"/>
           <a:lstStyle/>
           <a:p>
-            <a:pPr indent="0" marL="0">
+            <a:pPr marL="0" indent="0">
               <a:buNone/>
             </a:pPr>
             <a:r>
@@ -4501,7 +4325,7 @@
           <a:bodyPr wrap="square" lIns="0" tIns="0" rIns="0" bIns="0" rtlCol="0" anchor="ctr"/>
           <a:lstStyle/>
           <a:p>
-            <a:pPr indent="0" marL="0">
+            <a:pPr marL="0" indent="0">
               <a:buNone/>
             </a:pPr>
             <a:r>
@@ -4545,13 +4369,20 @@
             <a:prstDash val="solid"/>
           </a:ln>
           <a:effectLst>
-            <a:outerShdw sx="100000" sy="100000" kx="0" ky="0" algn="bl" rotWithShape="0" blurRad="127000" dist="25400" dir="5400000">
+            <a:outerShdw blurRad="127000" dist="25400" dir="5400000" algn="bl" rotWithShape="0">
               <a:srgbClr val="9AAAC4">
                 <a:alpha val="30000"/>
               </a:srgbClr>
             </a:outerShdw>
           </a:effectLst>
         </p:spPr>
+        <p:txBody>
+          <a:bodyPr/>
+          <a:lstStyle/>
+          <a:p>
+            <a:endParaRPr lang="en-US"/>
+          </a:p>
+        </p:txBody>
       </p:sp>
       <p:sp>
         <p:nvSpPr>
@@ -4574,11 +4405,11 @@
           <a:bodyPr wrap="square" lIns="0" tIns="0" rIns="0" bIns="0" rtlCol="0" anchor="ctr"/>
           <a:lstStyle/>
           <a:p>
-            <a:pPr indent="0" marL="0">
-              <a:buNone/>
-            </a:pPr>
-            <a:r>
-              <a:rPr lang="en-US" sz="1050" b="1" spc="150" kern="0" dirty="0">
+            <a:pPr marL="0" indent="0">
+              <a:buNone/>
+            </a:pPr>
+            <a:r>
+              <a:rPr lang="en-US" sz="1050" b="1" kern="0" spc="150" dirty="0">
                 <a:solidFill>
                   <a:srgbClr val="C07A22"/>
                 </a:solidFill>
@@ -4613,7 +4444,7 @@
           <a:bodyPr wrap="square" lIns="0" tIns="0" rIns="0" bIns="0" rtlCol="0" anchor="ctr"/>
           <a:lstStyle/>
           <a:p>
-            <a:pPr indent="0" marL="0">
+            <a:pPr marL="0" indent="0">
               <a:buNone/>
             </a:pPr>
             <a:r>
@@ -4652,7 +4483,7 @@
           <a:bodyPr wrap="square" lIns="0" tIns="0" rIns="0" bIns="0" rtlCol="0" anchor="t"/>
           <a:lstStyle/>
           <a:p>
-            <a:pPr indent="0" marL="0">
+            <a:pPr marL="0" indent="0">
               <a:buNone/>
             </a:pPr>
             <a:r>
@@ -4694,6 +4525,13 @@
             <a:prstDash val="solid"/>
           </a:ln>
         </p:spPr>
+        <p:txBody>
+          <a:bodyPr/>
+          <a:lstStyle/>
+          <a:p>
+            <a:endParaRPr lang="en-US"/>
+          </a:p>
+        </p:txBody>
       </p:sp>
       <p:sp>
         <p:nvSpPr>
@@ -4721,13 +4559,20 @@
             <a:prstDash val="solid"/>
           </a:ln>
           <a:effectLst>
-            <a:outerShdw sx="100000" sy="100000" kx="0" ky="0" algn="bl" rotWithShape="0" blurRad="127000" dist="25400" dir="5400000">
+            <a:outerShdw blurRad="127000" dist="25400" dir="5400000" algn="bl" rotWithShape="0">
               <a:srgbClr val="9AAAC4">
                 <a:alpha val="30000"/>
               </a:srgbClr>
             </a:outerShdw>
           </a:effectLst>
         </p:spPr>
+        <p:txBody>
+          <a:bodyPr/>
+          <a:lstStyle/>
+          <a:p>
+            <a:endParaRPr lang="en-US"/>
+          </a:p>
+        </p:txBody>
       </p:sp>
       <p:sp>
         <p:nvSpPr>
@@ -4750,11 +4595,11 @@
           <a:bodyPr wrap="square" lIns="0" tIns="0" rIns="0" bIns="0" rtlCol="0" anchor="ctr"/>
           <a:lstStyle/>
           <a:p>
-            <a:pPr indent="0" marL="0">
-              <a:buNone/>
-            </a:pPr>
-            <a:r>
-              <a:rPr lang="en-US" sz="1050" b="1" spc="150" kern="0" dirty="0">
+            <a:pPr marL="0" indent="0">
+              <a:buNone/>
+            </a:pPr>
+            <a:r>
+              <a:rPr lang="en-US" sz="1050" b="1" kern="0" spc="150" dirty="0">
                 <a:solidFill>
                   <a:srgbClr val="C07A22"/>
                 </a:solidFill>
@@ -4789,7 +4634,7 @@
           <a:bodyPr wrap="square" lIns="0" tIns="0" rIns="0" bIns="0" rtlCol="0" anchor="ctr"/>
           <a:lstStyle/>
           <a:p>
-            <a:pPr indent="0" marL="0">
+            <a:pPr marL="0" indent="0">
               <a:buNone/>
             </a:pPr>
             <a:r>
@@ -4828,7 +4673,7 @@
           <a:bodyPr wrap="square" lIns="0" tIns="0" rIns="0" bIns="0" rtlCol="0" anchor="t"/>
           <a:lstStyle/>
           <a:p>
-            <a:pPr indent="0" marL="0">
+            <a:pPr marL="0" indent="0">
               <a:buNone/>
             </a:pPr>
             <a:r>
@@ -4870,6 +4715,13 @@
             <a:prstDash val="solid"/>
           </a:ln>
         </p:spPr>
+        <p:txBody>
+          <a:bodyPr/>
+          <a:lstStyle/>
+          <a:p>
+            <a:endParaRPr lang="en-US"/>
+          </a:p>
+        </p:txBody>
       </p:sp>
       <p:sp>
         <p:nvSpPr>
@@ -4897,13 +4749,20 @@
             <a:prstDash val="solid"/>
           </a:ln>
           <a:effectLst>
-            <a:outerShdw sx="100000" sy="100000" kx="0" ky="0" algn="bl" rotWithShape="0" blurRad="127000" dist="25400" dir="5400000">
+            <a:outerShdw blurRad="127000" dist="25400" dir="5400000" algn="bl" rotWithShape="0">
               <a:srgbClr val="9AAAC4">
                 <a:alpha val="30000"/>
               </a:srgbClr>
             </a:outerShdw>
           </a:effectLst>
         </p:spPr>
+        <p:txBody>
+          <a:bodyPr/>
+          <a:lstStyle/>
+          <a:p>
+            <a:endParaRPr lang="en-US"/>
+          </a:p>
+        </p:txBody>
       </p:sp>
       <p:sp>
         <p:nvSpPr>
@@ -4926,11 +4785,11 @@
           <a:bodyPr wrap="square" lIns="0" tIns="0" rIns="0" bIns="0" rtlCol="0" anchor="ctr"/>
           <a:lstStyle/>
           <a:p>
-            <a:pPr indent="0" marL="0">
-              <a:buNone/>
-            </a:pPr>
-            <a:r>
-              <a:rPr lang="en-US" sz="1050" b="1" spc="150" kern="0" dirty="0">
+            <a:pPr marL="0" indent="0">
+              <a:buNone/>
+            </a:pPr>
+            <a:r>
+              <a:rPr lang="en-US" sz="1050" b="1" kern="0" spc="150" dirty="0">
                 <a:solidFill>
                   <a:srgbClr val="C07A22"/>
                 </a:solidFill>
@@ -4965,7 +4824,7 @@
           <a:bodyPr wrap="square" lIns="0" tIns="0" rIns="0" bIns="0" rtlCol="0" anchor="ctr"/>
           <a:lstStyle/>
           <a:p>
-            <a:pPr indent="0" marL="0">
+            <a:pPr marL="0" indent="0">
               <a:buNone/>
             </a:pPr>
             <a:r>
@@ -5004,7 +4863,7 @@
           <a:bodyPr wrap="square" lIns="0" tIns="0" rIns="0" bIns="0" rtlCol="0" anchor="t"/>
           <a:lstStyle/>
           <a:p>
-            <a:pPr indent="0" marL="0">
+            <a:pPr marL="0" indent="0">
               <a:buNone/>
             </a:pPr>
             <a:r>
@@ -5043,7 +4902,7 @@
           <a:bodyPr wrap="square" lIns="0" tIns="0" rIns="0" bIns="0" rtlCol="0" anchor="t"/>
           <a:lstStyle/>
           <a:p>
-            <a:pPr indent="0" marL="0">
+            <a:pPr marL="0" indent="0">
               <a:buNone/>
             </a:pPr>
             <a:r>
@@ -5107,7 +4966,7 @@
           <a:bodyPr wrap="square" lIns="0" tIns="0" rIns="0" bIns="0" rtlCol="0" anchor="ctr"/>
           <a:lstStyle/>
           <a:p>
-            <a:pPr indent="0" marL="0">
+            <a:pPr marL="0" indent="0">
               <a:buNone/>
             </a:pPr>
             <a:r>
@@ -5146,7 +5005,7 @@
           <a:bodyPr wrap="square" lIns="0" tIns="0" rIns="0" bIns="0" rtlCol="0" anchor="ctr"/>
           <a:lstStyle/>
           <a:p>
-            <a:pPr indent="0" marL="0">
+            <a:pPr marL="0" indent="0">
               <a:buNone/>
             </a:pPr>
             <a:r>
@@ -5190,13 +5049,20 @@
             <a:prstDash val="solid"/>
           </a:ln>
           <a:effectLst>
-            <a:outerShdw sx="100000" sy="100000" kx="0" ky="0" algn="bl" rotWithShape="0" blurRad="127000" dist="25400" dir="5400000">
+            <a:outerShdw blurRad="127000" dist="25400" dir="5400000" algn="bl" rotWithShape="0">
               <a:srgbClr val="9AAAC4">
                 <a:alpha val="30000"/>
               </a:srgbClr>
             </a:outerShdw>
           </a:effectLst>
         </p:spPr>
+        <p:txBody>
+          <a:bodyPr/>
+          <a:lstStyle/>
+          <a:p>
+            <a:endParaRPr lang="en-US"/>
+          </a:p>
+        </p:txBody>
       </p:sp>
       <p:sp>
         <p:nvSpPr>
@@ -5219,7 +5085,7 @@
           <a:bodyPr wrap="square" lIns="0" tIns="0" rIns="0" bIns="0" rtlCol="0" anchor="ctr"/>
           <a:lstStyle/>
           <a:p>
-            <a:pPr indent="0" marL="0">
+            <a:pPr marL="0" indent="0">
               <a:buNone/>
             </a:pPr>
             <a:r>
@@ -5261,6 +5127,13 @@
             <a:prstDash val="solid"/>
           </a:ln>
         </p:spPr>
+        <p:txBody>
+          <a:bodyPr/>
+          <a:lstStyle/>
+          <a:p>
+            <a:endParaRPr lang="en-US"/>
+          </a:p>
+        </p:txBody>
       </p:sp>
       <p:sp>
         <p:nvSpPr>
@@ -5283,7 +5156,7 @@
           <a:bodyPr wrap="square" lIns="0" tIns="0" rIns="0" bIns="0" rtlCol="0" anchor="ctr"/>
           <a:lstStyle/>
           <a:p>
-            <a:pPr algn="ctr" indent="0" marL="0">
+            <a:pPr marL="0" indent="0" algn="ctr">
               <a:buNone/>
             </a:pPr>
             <a:r>
@@ -5322,7 +5195,7 @@
           <a:bodyPr wrap="square" lIns="0" tIns="0" rIns="0" bIns="0" rtlCol="0" anchor="ctr"/>
           <a:lstStyle/>
           <a:p>
-            <a:pPr indent="0" marL="0">
+            <a:pPr marL="0" indent="0">
               <a:buNone/>
             </a:pPr>
             <a:r>
@@ -5361,7 +5234,7 @@
           <a:bodyPr wrap="square" lIns="0" tIns="0" rIns="0" bIns="0" rtlCol="0" anchor="t"/>
           <a:lstStyle/>
           <a:p>
-            <a:pPr indent="0" marL="0">
+            <a:pPr marL="0" indent="0">
               <a:buNone/>
             </a:pPr>
             <a:r>
@@ -5403,6 +5276,13 @@
             <a:prstDash val="solid"/>
           </a:ln>
         </p:spPr>
+        <p:txBody>
+          <a:bodyPr/>
+          <a:lstStyle/>
+          <a:p>
+            <a:endParaRPr lang="en-US"/>
+          </a:p>
+        </p:txBody>
       </p:sp>
       <p:sp>
         <p:nvSpPr>
@@ -5425,7 +5305,7 @@
           <a:bodyPr wrap="square" lIns="0" tIns="0" rIns="0" bIns="0" rtlCol="0" anchor="ctr"/>
           <a:lstStyle/>
           <a:p>
-            <a:pPr algn="ctr" indent="0" marL="0">
+            <a:pPr marL="0" indent="0" algn="ctr">
               <a:buNone/>
             </a:pPr>
             <a:r>
@@ -5464,7 +5344,7 @@
           <a:bodyPr wrap="square" lIns="0" tIns="0" rIns="0" bIns="0" rtlCol="0" anchor="ctr"/>
           <a:lstStyle/>
           <a:p>
-            <a:pPr indent="0" marL="0">
+            <a:pPr marL="0" indent="0">
               <a:buNone/>
             </a:pPr>
             <a:r>
@@ -5503,7 +5383,7 @@
           <a:bodyPr wrap="square" lIns="0" tIns="0" rIns="0" bIns="0" rtlCol="0" anchor="t"/>
           <a:lstStyle/>
           <a:p>
-            <a:pPr indent="0" marL="0">
+            <a:pPr marL="0" indent="0">
               <a:buNone/>
             </a:pPr>
             <a:r>
@@ -5545,6 +5425,13 @@
             <a:prstDash val="solid"/>
           </a:ln>
         </p:spPr>
+        <p:txBody>
+          <a:bodyPr/>
+          <a:lstStyle/>
+          <a:p>
+            <a:endParaRPr lang="en-US"/>
+          </a:p>
+        </p:txBody>
       </p:sp>
       <p:sp>
         <p:nvSpPr>
@@ -5567,7 +5454,7 @@
           <a:bodyPr wrap="square" lIns="0" tIns="0" rIns="0" bIns="0" rtlCol="0" anchor="ctr"/>
           <a:lstStyle/>
           <a:p>
-            <a:pPr algn="ctr" indent="0" marL="0">
+            <a:pPr marL="0" indent="0" algn="ctr">
               <a:buNone/>
             </a:pPr>
             <a:r>
@@ -5606,7 +5493,7 @@
           <a:bodyPr wrap="square" lIns="0" tIns="0" rIns="0" bIns="0" rtlCol="0" anchor="ctr"/>
           <a:lstStyle/>
           <a:p>
-            <a:pPr indent="0" marL="0">
+            <a:pPr marL="0" indent="0">
               <a:buNone/>
             </a:pPr>
             <a:r>
@@ -5645,7 +5532,7 @@
           <a:bodyPr wrap="square" lIns="0" tIns="0" rIns="0" bIns="0" rtlCol="0" anchor="t"/>
           <a:lstStyle/>
           <a:p>
-            <a:pPr indent="0" marL="0">
+            <a:pPr marL="0" indent="0">
               <a:buNone/>
             </a:pPr>
             <a:r>
@@ -5709,7 +5596,7 @@
           <a:bodyPr wrap="square" lIns="0" tIns="0" rIns="0" bIns="0" rtlCol="0" anchor="ctr"/>
           <a:lstStyle/>
           <a:p>
-            <a:pPr indent="0" marL="0">
+            <a:pPr marL="0" indent="0">
               <a:buNone/>
             </a:pPr>
             <a:r>
@@ -5748,7 +5635,7 @@
           <a:bodyPr wrap="square" lIns="0" tIns="0" rIns="0" bIns="0" rtlCol="0" anchor="ctr"/>
           <a:lstStyle/>
           <a:p>
-            <a:pPr indent="0" marL="0">
+            <a:pPr marL="0" indent="0">
               <a:buNone/>
             </a:pPr>
             <a:r>
@@ -5792,13 +5679,20 @@
             <a:prstDash val="solid"/>
           </a:ln>
           <a:effectLst>
-            <a:outerShdw sx="100000" sy="100000" kx="0" ky="0" algn="bl" rotWithShape="0" blurRad="127000" dist="25400" dir="5400000">
+            <a:outerShdw blurRad="127000" dist="25400" dir="5400000" algn="bl" rotWithShape="0">
               <a:srgbClr val="9AAAC4">
                 <a:alpha val="30000"/>
               </a:srgbClr>
             </a:outerShdw>
           </a:effectLst>
         </p:spPr>
+        <p:txBody>
+          <a:bodyPr/>
+          <a:lstStyle/>
+          <a:p>
+            <a:endParaRPr lang="en-US"/>
+          </a:p>
+        </p:txBody>
       </p:sp>
       <p:sp>
         <p:nvSpPr>
@@ -5821,7 +5715,7 @@
           <a:bodyPr wrap="square" lIns="0" tIns="0" rIns="0" bIns="0" rtlCol="0" anchor="ctr"/>
           <a:lstStyle/>
           <a:p>
-            <a:pPr algn="ctr" indent="0" marL="0">
+            <a:pPr marL="0" indent="0" algn="ctr">
               <a:buNone/>
             </a:pPr>
             <a:r>
@@ -5860,7 +5754,7 @@
           <a:bodyPr wrap="square" lIns="0" tIns="0" rIns="0" bIns="0" rtlCol="0" anchor="ctr"/>
           <a:lstStyle/>
           <a:p>
-            <a:pPr algn="ctr" indent="0" marL="0">
+            <a:pPr marL="0" indent="0" algn="ctr">
               <a:buNone/>
             </a:pPr>
             <a:r>
@@ -5904,13 +5798,20 @@
             <a:prstDash val="solid"/>
           </a:ln>
           <a:effectLst>
-            <a:outerShdw sx="100000" sy="100000" kx="0" ky="0" algn="bl" rotWithShape="0" blurRad="127000" dist="25400" dir="5400000">
+            <a:outerShdw blurRad="127000" dist="25400" dir="5400000" algn="bl" rotWithShape="0">
               <a:srgbClr val="9AAAC4">
                 <a:alpha val="30000"/>
               </a:srgbClr>
             </a:outerShdw>
           </a:effectLst>
         </p:spPr>
+        <p:txBody>
+          <a:bodyPr/>
+          <a:lstStyle/>
+          <a:p>
+            <a:endParaRPr lang="en-US"/>
+          </a:p>
+        </p:txBody>
       </p:sp>
       <p:sp>
         <p:nvSpPr>
@@ -5933,7 +5834,7 @@
           <a:bodyPr wrap="square" lIns="0" tIns="0" rIns="0" bIns="0" rtlCol="0" anchor="ctr"/>
           <a:lstStyle/>
           <a:p>
-            <a:pPr algn="ctr" indent="0" marL="0">
+            <a:pPr marL="0" indent="0" algn="ctr">
               <a:buNone/>
             </a:pPr>
             <a:r>
@@ -5972,7 +5873,7 @@
           <a:bodyPr wrap="square" lIns="0" tIns="0" rIns="0" bIns="0" rtlCol="0" anchor="ctr"/>
           <a:lstStyle/>
           <a:p>
-            <a:pPr algn="ctr" indent="0" marL="0">
+            <a:pPr marL="0" indent="0" algn="ctr">
               <a:buNone/>
             </a:pPr>
             <a:r>
@@ -6016,13 +5917,20 @@
             <a:prstDash val="solid"/>
           </a:ln>
           <a:effectLst>
-            <a:outerShdw sx="100000" sy="100000" kx="0" ky="0" algn="bl" rotWithShape="0" blurRad="127000" dist="25400" dir="5400000">
+            <a:outerShdw blurRad="127000" dist="25400" dir="5400000" algn="bl" rotWithShape="0">
               <a:srgbClr val="9AAAC4">
                 <a:alpha val="30000"/>
               </a:srgbClr>
             </a:outerShdw>
           </a:effectLst>
         </p:spPr>
+        <p:txBody>
+          <a:bodyPr/>
+          <a:lstStyle/>
+          <a:p>
+            <a:endParaRPr lang="en-US"/>
+          </a:p>
+        </p:txBody>
       </p:sp>
       <p:sp>
         <p:nvSpPr>
@@ -6045,7 +5953,7 @@
           <a:bodyPr wrap="square" lIns="0" tIns="0" rIns="0" bIns="0" rtlCol="0" anchor="ctr"/>
           <a:lstStyle/>
           <a:p>
-            <a:pPr algn="ctr" indent="0" marL="0">
+            <a:pPr marL="0" indent="0" algn="ctr">
               <a:buNone/>
             </a:pPr>
             <a:r>
@@ -6084,7 +5992,7 @@
           <a:bodyPr wrap="square" lIns="0" tIns="0" rIns="0" bIns="0" rtlCol="0" anchor="ctr"/>
           <a:lstStyle/>
           <a:p>
-            <a:pPr algn="ctr" indent="0" marL="0">
+            <a:pPr marL="0" indent="0" algn="ctr">
               <a:buNone/>
             </a:pPr>
             <a:r>
@@ -6128,13 +6036,20 @@
             <a:prstDash val="solid"/>
           </a:ln>
           <a:effectLst>
-            <a:outerShdw sx="100000" sy="100000" kx="0" ky="0" algn="bl" rotWithShape="0" blurRad="127000" dist="25400" dir="5400000">
+            <a:outerShdw blurRad="127000" dist="25400" dir="5400000" algn="bl" rotWithShape="0">
               <a:srgbClr val="9AAAC4">
                 <a:alpha val="30000"/>
               </a:srgbClr>
             </a:outerShdw>
           </a:effectLst>
         </p:spPr>
+        <p:txBody>
+          <a:bodyPr/>
+          <a:lstStyle/>
+          <a:p>
+            <a:endParaRPr lang="en-US"/>
+          </a:p>
+        </p:txBody>
       </p:sp>
       <p:sp>
         <p:nvSpPr>
@@ -6157,7 +6072,7 @@
           <a:bodyPr wrap="square" lIns="0" tIns="0" rIns="0" bIns="0" rtlCol="0" anchor="ctr"/>
           <a:lstStyle/>
           <a:p>
-            <a:pPr algn="ctr" indent="0" marL="0">
+            <a:pPr marL="0" indent="0" algn="ctr">
               <a:buNone/>
             </a:pPr>
             <a:r>
@@ -6196,7 +6111,7 @@
           <a:bodyPr wrap="square" lIns="0" tIns="0" rIns="0" bIns="0" rtlCol="0" anchor="ctr"/>
           <a:lstStyle/>
           <a:p>
-            <a:pPr algn="ctr" indent="0" marL="0">
+            <a:pPr marL="0" indent="0" algn="ctr">
               <a:buNone/>
             </a:pPr>
             <a:r>
@@ -6240,13 +6155,20 @@
             <a:prstDash val="solid"/>
           </a:ln>
           <a:effectLst>
-            <a:outerShdw sx="100000" sy="100000" kx="0" ky="0" algn="bl" rotWithShape="0" blurRad="127000" dist="25400" dir="5400000">
+            <a:outerShdw blurRad="127000" dist="25400" dir="5400000" algn="bl" rotWithShape="0">
               <a:srgbClr val="9AAAC4">
                 <a:alpha val="30000"/>
               </a:srgbClr>
             </a:outerShdw>
           </a:effectLst>
         </p:spPr>
+        <p:txBody>
+          <a:bodyPr/>
+          <a:lstStyle/>
+          <a:p>
+            <a:endParaRPr lang="en-US"/>
+          </a:p>
+        </p:txBody>
       </p:sp>
       <p:sp>
         <p:nvSpPr>
@@ -6269,7 +6191,7 @@
           <a:bodyPr wrap="square" lIns="0" tIns="0" rIns="0" bIns="0" rtlCol="0" anchor="ctr"/>
           <a:lstStyle/>
           <a:p>
-            <a:pPr algn="ctr" indent="0" marL="0">
+            <a:pPr marL="0" indent="0" algn="ctr">
               <a:buNone/>
             </a:pPr>
             <a:r>
@@ -6308,7 +6230,7 @@
           <a:bodyPr wrap="square" lIns="0" tIns="0" rIns="0" bIns="0" rtlCol="0" anchor="ctr"/>
           <a:lstStyle/>
           <a:p>
-            <a:pPr algn="ctr" indent="0" marL="0">
+            <a:pPr marL="0" indent="0" algn="ctr">
               <a:buNone/>
             </a:pPr>
             <a:r>
@@ -6347,7 +6269,7 @@
           <a:bodyPr wrap="square" lIns="0" tIns="0" rIns="0" bIns="0" rtlCol="0" anchor="ctr"/>
           <a:lstStyle/>
           <a:p>
-            <a:pPr indent="0" marL="0">
+            <a:pPr marL="0" indent="0">
               <a:buNone/>
             </a:pPr>
             <a:r>
@@ -6496,7 +6418,7 @@
           <a:bodyPr wrap="square" lIns="0" tIns="0" rIns="0" bIns="0" rtlCol="0" anchor="ctr"/>
           <a:lstStyle/>
           <a:p>
-            <a:pPr indent="0" marL="0">
+            <a:pPr marL="0" indent="0">
               <a:buNone/>
             </a:pPr>
             <a:r>
@@ -6535,7 +6457,7 @@
           <a:bodyPr wrap="square" lIns="0" tIns="0" rIns="0" bIns="0" rtlCol="0" anchor="ctr"/>
           <a:lstStyle/>
           <a:p>
-            <a:pPr indent="0" marL="0">
+            <a:pPr marL="0" indent="0">
               <a:buNone/>
             </a:pPr>
             <a:r>
@@ -6579,13 +6501,20 @@
             <a:prstDash val="solid"/>
           </a:ln>
           <a:effectLst>
-            <a:outerShdw sx="100000" sy="100000" kx="0" ky="0" algn="bl" rotWithShape="0" blurRad="127000" dist="25400" dir="5400000">
+            <a:outerShdw blurRad="127000" dist="25400" dir="5400000" algn="bl" rotWithShape="0">
               <a:srgbClr val="9AAAC4">
                 <a:alpha val="30000"/>
               </a:srgbClr>
             </a:outerShdw>
           </a:effectLst>
         </p:spPr>
+        <p:txBody>
+          <a:bodyPr/>
+          <a:lstStyle/>
+          <a:p>
+            <a:endParaRPr lang="en-US"/>
+          </a:p>
+        </p:txBody>
       </p:sp>
       <p:sp>
         <p:nvSpPr>
@@ -6608,7 +6537,7 @@
           <a:bodyPr wrap="square" lIns="0" tIns="0" rIns="0" bIns="0" rtlCol="0" anchor="ctr"/>
           <a:lstStyle/>
           <a:p>
-            <a:pPr indent="0" marL="0">
+            <a:pPr marL="0" indent="0">
               <a:buNone/>
             </a:pPr>
             <a:r>
@@ -6732,7 +6661,7 @@
           <a:bodyPr wrap="square" lIns="0" tIns="0" rIns="0" bIns="0" rtlCol="0" anchor="ctr"/>
           <a:lstStyle/>
           <a:p>
-            <a:pPr indent="0" marL="0">
+            <a:pPr marL="0" indent="0">
               <a:buNone/>
             </a:pPr>
             <a:r>
@@ -6776,13 +6705,20 @@
             <a:prstDash val="solid"/>
           </a:ln>
           <a:effectLst>
-            <a:outerShdw sx="100000" sy="100000" kx="0" ky="0" algn="bl" rotWithShape="0" blurRad="127000" dist="25400" dir="5400000">
+            <a:outerShdw blurRad="127000" dist="25400" dir="5400000" algn="bl" rotWithShape="0">
               <a:srgbClr val="9AAAC4">
                 <a:alpha val="30000"/>
               </a:srgbClr>
             </a:outerShdw>
           </a:effectLst>
         </p:spPr>
+        <p:txBody>
+          <a:bodyPr/>
+          <a:lstStyle/>
+          <a:p>
+            <a:endParaRPr lang="en-US"/>
+          </a:p>
+        </p:txBody>
       </p:sp>
       <p:sp>
         <p:nvSpPr>
@@ -6805,7 +6741,7 @@
           <a:bodyPr wrap="square" lIns="0" tIns="0" rIns="0" bIns="0" rtlCol="0" anchor="ctr"/>
           <a:lstStyle/>
           <a:p>
-            <a:pPr indent="0" marL="0">
+            <a:pPr marL="0" indent="0">
               <a:buNone/>
             </a:pPr>
             <a:r>
@@ -6844,7 +6780,7 @@
           <a:bodyPr wrap="square" lIns="0" tIns="0" rIns="0" bIns="0" rtlCol="0" anchor="t"/>
           <a:lstStyle/>
           <a:p>
-            <a:pPr indent="0" marL="0">
+            <a:pPr marL="0" indent="0">
               <a:buNone/>
             </a:pPr>
             <a:r>
@@ -6883,7 +6819,7 @@
           <a:bodyPr wrap="square" lIns="0" tIns="0" rIns="0" bIns="0" rtlCol="0" anchor="ctr"/>
           <a:lstStyle/>
           <a:p>
-            <a:pPr indent="0" marL="0">
+            <a:pPr marL="0" indent="0">
               <a:lnSpc>
                 <a:spcPts val="2600"/>
               </a:lnSpc>
@@ -6903,7 +6839,7 @@
             <a:endParaRPr lang="en-US" sz="1600" dirty="0"/>
           </a:p>
           <a:p>
-            <a:pPr indent="0" marL="0">
+            <a:pPr marL="0" indent="0">
               <a:lnSpc>
                 <a:spcPts val="2600"/>
               </a:lnSpc>
@@ -6945,7 +6881,7 @@
           <a:bodyPr wrap="square" lIns="0" tIns="0" rIns="0" bIns="0" rtlCol="0" anchor="ctr"/>
           <a:lstStyle/>
           <a:p>
-            <a:pPr indent="0" marL="0">
+            <a:pPr marL="0" indent="0">
               <a:buNone/>
             </a:pPr>
             <a:r>
@@ -7009,7 +6945,7 @@
           <a:bodyPr wrap="square" lIns="0" tIns="0" rIns="0" bIns="0" rtlCol="0" anchor="ctr"/>
           <a:lstStyle/>
           <a:p>
-            <a:pPr indent="0" marL="0">
+            <a:pPr marL="0" indent="0">
               <a:buNone/>
             </a:pPr>
             <a:r>
@@ -7048,7 +6984,7 @@
           <a:bodyPr wrap="square" lIns="0" tIns="0" rIns="0" bIns="0" rtlCol="0" anchor="ctr"/>
           <a:lstStyle/>
           <a:p>
-            <a:pPr indent="0" marL="0">
+            <a:pPr marL="0" indent="0">
               <a:buNone/>
             </a:pPr>
             <a:r>
@@ -7092,13 +7028,20 @@
             <a:prstDash val="solid"/>
           </a:ln>
           <a:effectLst>
-            <a:outerShdw sx="100000" sy="100000" kx="0" ky="0" algn="bl" rotWithShape="0" blurRad="127000" dist="25400" dir="5400000">
+            <a:outerShdw blurRad="127000" dist="25400" dir="5400000" algn="bl" rotWithShape="0">
               <a:srgbClr val="9AAAC4">
                 <a:alpha val="30000"/>
               </a:srgbClr>
             </a:outerShdw>
           </a:effectLst>
         </p:spPr>
+        <p:txBody>
+          <a:bodyPr/>
+          <a:lstStyle/>
+          <a:p>
+            <a:endParaRPr lang="en-US"/>
+          </a:p>
+        </p:txBody>
       </p:sp>
       <p:sp>
         <p:nvSpPr>
@@ -7121,7 +7064,7 @@
           <a:bodyPr wrap="square" lIns="0" tIns="0" rIns="0" bIns="0" rtlCol="0" anchor="ctr"/>
           <a:lstStyle/>
           <a:p>
-            <a:pPr indent="0" marL="0">
+            <a:pPr marL="0" indent="0">
               <a:buNone/>
             </a:pPr>
             <a:r>
@@ -7250,13 +7193,20 @@
             <a:prstDash val="solid"/>
           </a:ln>
           <a:effectLst>
-            <a:outerShdw sx="100000" sy="100000" kx="0" ky="0" algn="bl" rotWithShape="0" blurRad="127000" dist="25400" dir="5400000">
+            <a:outerShdw blurRad="127000" dist="25400" dir="5400000" algn="bl" rotWithShape="0">
               <a:srgbClr val="9AAAC4">
                 <a:alpha val="30000"/>
               </a:srgbClr>
             </a:outerShdw>
           </a:effectLst>
         </p:spPr>
+        <p:txBody>
+          <a:bodyPr/>
+          <a:lstStyle/>
+          <a:p>
+            <a:endParaRPr lang="en-US"/>
+          </a:p>
+        </p:txBody>
       </p:sp>
       <p:sp>
         <p:nvSpPr>
@@ -7279,7 +7229,7 @@
           <a:bodyPr wrap="square" lIns="0" tIns="0" rIns="0" bIns="0" rtlCol="0" anchor="ctr"/>
           <a:lstStyle/>
           <a:p>
-            <a:pPr indent="0" marL="0">
+            <a:pPr marL="0" indent="0">
               <a:buNone/>
             </a:pPr>
             <a:r>
@@ -7403,7 +7353,7 @@
           <a:bodyPr wrap="square" lIns="0" tIns="0" rIns="0" bIns="0" rtlCol="0" anchor="ctr"/>
           <a:lstStyle/>
           <a:p>
-            <a:pPr indent="0" marL="0">
+            <a:pPr marL="0" indent="0">
               <a:buNone/>
             </a:pPr>
             <a:r>
@@ -7467,7 +7417,7 @@
           <a:bodyPr wrap="square" lIns="0" tIns="0" rIns="0" bIns="0" rtlCol="0" anchor="ctr"/>
           <a:lstStyle/>
           <a:p>
-            <a:pPr indent="0" marL="0">
+            <a:pPr marL="0" indent="0">
               <a:buNone/>
             </a:pPr>
             <a:r>
@@ -7506,7 +7456,7 @@
           <a:bodyPr wrap="square" lIns="0" tIns="0" rIns="0" bIns="0" rtlCol="0" anchor="ctr"/>
           <a:lstStyle/>
           <a:p>
-            <a:pPr indent="0" marL="0">
+            <a:pPr marL="0" indent="0">
               <a:buNone/>
             </a:pPr>
             <a:r>
@@ -7550,13 +7500,20 @@
             <a:prstDash val="solid"/>
           </a:ln>
           <a:effectLst>
-            <a:outerShdw sx="100000" sy="100000" kx="0" ky="0" algn="bl" rotWithShape="0" blurRad="127000" dist="25400" dir="5400000">
+            <a:outerShdw blurRad="127000" dist="25400" dir="5400000" algn="bl" rotWithShape="0">
               <a:srgbClr val="9AAAC4">
                 <a:alpha val="30000"/>
               </a:srgbClr>
             </a:outerShdw>
           </a:effectLst>
         </p:spPr>
+        <p:txBody>
+          <a:bodyPr/>
+          <a:lstStyle/>
+          <a:p>
+            <a:endParaRPr lang="en-US"/>
+          </a:p>
+        </p:txBody>
       </p:sp>
       <p:sp>
         <p:nvSpPr>
@@ -7579,7 +7536,7 @@
           <a:bodyPr wrap="square" lIns="0" tIns="0" rIns="0" bIns="0" rtlCol="0" anchor="ctr"/>
           <a:lstStyle/>
           <a:p>
-            <a:pPr indent="0" marL="0">
+            <a:pPr marL="0" indent="0">
               <a:buNone/>
             </a:pPr>
             <a:r>
@@ -7729,13 +7686,20 @@
             <a:prstDash val="solid"/>
           </a:ln>
           <a:effectLst>
-            <a:outerShdw sx="100000" sy="100000" kx="0" ky="0" algn="bl" rotWithShape="0" blurRad="127000" dist="25400" dir="5400000">
+            <a:outerShdw blurRad="127000" dist="25400" dir="5400000" algn="bl" rotWithShape="0">
               <a:srgbClr val="9AAAC4">
                 <a:alpha val="30000"/>
               </a:srgbClr>
             </a:outerShdw>
           </a:effectLst>
         </p:spPr>
+        <p:txBody>
+          <a:bodyPr/>
+          <a:lstStyle/>
+          <a:p>
+            <a:endParaRPr lang="en-US"/>
+          </a:p>
+        </p:txBody>
       </p:sp>
       <p:sp>
         <p:nvSpPr>
@@ -7758,7 +7722,7 @@
           <a:bodyPr wrap="square" lIns="0" tIns="0" rIns="0" bIns="0" rtlCol="0" anchor="ctr"/>
           <a:lstStyle/>
           <a:p>
-            <a:pPr indent="0" marL="0">
+            <a:pPr marL="0" indent="0">
               <a:buNone/>
             </a:pPr>
             <a:r>
@@ -7928,7 +7892,7 @@
           <a:bodyPr wrap="square" lIns="0" tIns="0" rIns="0" bIns="0" rtlCol="0" anchor="ctr"/>
           <a:lstStyle/>
           <a:p>
-            <a:pPr indent="0" marL="0">
+            <a:pPr marL="0" indent="0">
               <a:buNone/>
             </a:pPr>
             <a:r>
@@ -7967,7 +7931,7 @@
           <a:bodyPr wrap="square" lIns="0" tIns="0" rIns="0" bIns="0" rtlCol="0" anchor="ctr"/>
           <a:lstStyle/>
           <a:p>
-            <a:pPr indent="0" marL="0">
+            <a:pPr marL="0" indent="0">
               <a:buNone/>
             </a:pPr>
             <a:r>
@@ -8011,13 +7975,20 @@
             <a:prstDash val="solid"/>
           </a:ln>
           <a:effectLst>
-            <a:outerShdw sx="100000" sy="100000" kx="0" ky="0" algn="bl" rotWithShape="0" blurRad="127000" dist="25400" dir="5400000">
+            <a:outerShdw blurRad="127000" dist="25400" dir="5400000" algn="bl" rotWithShape="0">
               <a:srgbClr val="9AAAC4">
                 <a:alpha val="30000"/>
               </a:srgbClr>
             </a:outerShdw>
           </a:effectLst>
         </p:spPr>
+        <p:txBody>
+          <a:bodyPr/>
+          <a:lstStyle/>
+          <a:p>
+            <a:endParaRPr lang="en-US"/>
+          </a:p>
+        </p:txBody>
       </p:sp>
       <p:sp>
         <p:nvSpPr>
@@ -8043,6 +8014,13 @@
             <a:prstDash val="solid"/>
           </a:ln>
         </p:spPr>
+        <p:txBody>
+          <a:bodyPr/>
+          <a:lstStyle/>
+          <a:p>
+            <a:endParaRPr lang="en-US"/>
+          </a:p>
+        </p:txBody>
       </p:sp>
       <p:sp>
         <p:nvSpPr>
@@ -8065,7 +8043,7 @@
           <a:bodyPr wrap="square" lIns="0" tIns="0" rIns="0" bIns="0" rtlCol="0" anchor="ctr"/>
           <a:lstStyle/>
           <a:p>
-            <a:pPr algn="ctr" indent="0" marL="0">
+            <a:pPr marL="0" indent="0" algn="ctr">
               <a:buNone/>
             </a:pPr>
             <a:r>
@@ -8104,7 +8082,7 @@
           <a:bodyPr wrap="square" lIns="0" tIns="0" rIns="0" bIns="0" rtlCol="0" anchor="ctr"/>
           <a:lstStyle/>
           <a:p>
-            <a:pPr indent="0" marL="0">
+            <a:pPr marL="0" indent="0">
               <a:buNone/>
             </a:pPr>
             <a:r>
@@ -8143,7 +8121,7 @@
           <a:bodyPr wrap="square" lIns="0" tIns="0" rIns="0" bIns="0" rtlCol="0" anchor="t"/>
           <a:lstStyle/>
           <a:p>
-            <a:pPr indent="0" marL="0">
+            <a:pPr marL="0" indent="0">
               <a:buNone/>
             </a:pPr>
             <a:r>
@@ -8187,13 +8165,20 @@
             <a:prstDash val="solid"/>
           </a:ln>
           <a:effectLst>
-            <a:outerShdw sx="100000" sy="100000" kx="0" ky="0" algn="bl" rotWithShape="0" blurRad="127000" dist="25400" dir="5400000">
+            <a:outerShdw blurRad="127000" dist="25400" dir="5400000" algn="bl" rotWithShape="0">
               <a:srgbClr val="9AAAC4">
                 <a:alpha val="30000"/>
               </a:srgbClr>
             </a:outerShdw>
           </a:effectLst>
         </p:spPr>
+        <p:txBody>
+          <a:bodyPr/>
+          <a:lstStyle/>
+          <a:p>
+            <a:endParaRPr lang="en-US"/>
+          </a:p>
+        </p:txBody>
       </p:sp>
       <p:sp>
         <p:nvSpPr>
@@ -8219,6 +8204,13 @@
             <a:prstDash val="solid"/>
           </a:ln>
         </p:spPr>
+        <p:txBody>
+          <a:bodyPr/>
+          <a:lstStyle/>
+          <a:p>
+            <a:endParaRPr lang="en-US"/>
+          </a:p>
+        </p:txBody>
       </p:sp>
       <p:sp>
         <p:nvSpPr>
@@ -8241,7 +8233,7 @@
           <a:bodyPr wrap="square" lIns="0" tIns="0" rIns="0" bIns="0" rtlCol="0" anchor="ctr"/>
           <a:lstStyle/>
           <a:p>
-            <a:pPr algn="ctr" indent="0" marL="0">
+            <a:pPr marL="0" indent="0" algn="ctr">
               <a:buNone/>
             </a:pPr>
             <a:r>
@@ -8280,7 +8272,7 @@
           <a:bodyPr wrap="square" lIns="0" tIns="0" rIns="0" bIns="0" rtlCol="0" anchor="ctr"/>
           <a:lstStyle/>
           <a:p>
-            <a:pPr indent="0" marL="0">
+            <a:pPr marL="0" indent="0">
               <a:buNone/>
             </a:pPr>
             <a:r>
@@ -8319,7 +8311,7 @@
           <a:bodyPr wrap="square" lIns="0" tIns="0" rIns="0" bIns="0" rtlCol="0" anchor="t"/>
           <a:lstStyle/>
           <a:p>
-            <a:pPr indent="0" marL="0">
+            <a:pPr marL="0" indent="0">
               <a:buNone/>
             </a:pPr>
             <a:r>
@@ -8363,13 +8355,20 @@
             <a:prstDash val="solid"/>
           </a:ln>
           <a:effectLst>
-            <a:outerShdw sx="100000" sy="100000" kx="0" ky="0" algn="bl" rotWithShape="0" blurRad="127000" dist="25400" dir="5400000">
+            <a:outerShdw blurRad="127000" dist="25400" dir="5400000" algn="bl" rotWithShape="0">
               <a:srgbClr val="9AAAC4">
                 <a:alpha val="30000"/>
               </a:srgbClr>
             </a:outerShdw>
           </a:effectLst>
         </p:spPr>
+        <p:txBody>
+          <a:bodyPr/>
+          <a:lstStyle/>
+          <a:p>
+            <a:endParaRPr lang="en-US"/>
+          </a:p>
+        </p:txBody>
       </p:sp>
       <p:sp>
         <p:nvSpPr>
@@ -8395,6 +8394,13 @@
             <a:prstDash val="solid"/>
           </a:ln>
         </p:spPr>
+        <p:txBody>
+          <a:bodyPr/>
+          <a:lstStyle/>
+          <a:p>
+            <a:endParaRPr lang="en-US"/>
+          </a:p>
+        </p:txBody>
       </p:sp>
       <p:sp>
         <p:nvSpPr>
@@ -8417,7 +8423,7 @@
           <a:bodyPr wrap="square" lIns="0" tIns="0" rIns="0" bIns="0" rtlCol="0" anchor="ctr"/>
           <a:lstStyle/>
           <a:p>
-            <a:pPr algn="ctr" indent="0" marL="0">
+            <a:pPr marL="0" indent="0" algn="ctr">
               <a:buNone/>
             </a:pPr>
             <a:r>
@@ -8456,7 +8462,7 @@
           <a:bodyPr wrap="square" lIns="0" tIns="0" rIns="0" bIns="0" rtlCol="0" anchor="ctr"/>
           <a:lstStyle/>
           <a:p>
-            <a:pPr indent="0" marL="0">
+            <a:pPr marL="0" indent="0">
               <a:buNone/>
             </a:pPr>
             <a:r>
@@ -8495,7 +8501,7 @@
           <a:bodyPr wrap="square" lIns="0" tIns="0" rIns="0" bIns="0" rtlCol="0" anchor="t"/>
           <a:lstStyle/>
           <a:p>
-            <a:pPr indent="0" marL="0">
+            <a:pPr marL="0" indent="0">
               <a:buNone/>
             </a:pPr>
             <a:r>
@@ -8529,6 +8535,7 @@
         <a:solidFill>
           <a:srgbClr val="12294F"/>
         </a:solidFill>
+        <a:effectLst/>
       </p:bgPr>
     </p:bg>
     <p:spTree>
@@ -8566,7 +8573,7 @@
           <a:bodyPr wrap="square" lIns="0" tIns="0" rIns="0" bIns="0" rtlCol="0" anchor="ctr"/>
           <a:lstStyle/>
           <a:p>
-            <a:pPr indent="0" marL="0">
+            <a:pPr marL="0" indent="0">
               <a:buNone/>
             </a:pPr>
             <a:r>
@@ -8605,7 +8612,7 @@
           <a:bodyPr wrap="square" lIns="0" tIns="0" rIns="0" bIns="0" rtlCol="0" anchor="ctr"/>
           <a:lstStyle/>
           <a:p>
-            <a:pPr indent="0" marL="0">
+            <a:pPr marL="0" indent="0">
               <a:buNone/>
             </a:pPr>
             <a:r>
@@ -8649,6 +8656,13 @@
             <a:prstDash val="solid"/>
           </a:ln>
         </p:spPr>
+        <p:txBody>
+          <a:bodyPr/>
+          <a:lstStyle/>
+          <a:p>
+            <a:endParaRPr lang="en-US"/>
+          </a:p>
+        </p:txBody>
       </p:sp>
       <p:sp>
         <p:nvSpPr>
@@ -8671,7 +8685,7 @@
           <a:bodyPr wrap="square" lIns="0" tIns="0" rIns="0" bIns="0" rtlCol="0" anchor="ctr"/>
           <a:lstStyle/>
           <a:p>
-            <a:pPr algn="ctr" indent="0" marL="0">
+            <a:pPr marL="0" indent="0" algn="ctr">
               <a:buNone/>
             </a:pPr>
             <a:r>
@@ -8682,7 +8696,7 @@
                 <a:latin typeface="Courier New" pitchFamily="34" charset="0"/>
                 <a:ea typeface="Courier New" pitchFamily="34" charset="-122"/>
                 <a:cs typeface="Courier New" pitchFamily="34" charset="-120"/>
-                <a:hlinkClick r:id="rId1" invalidUrl="" action="" tgtFrame="" tooltip="" history="1" highlightClick="0" endSnd="0">
+                <a:hlinkClick r:id="rId3">
                   <a:extLst>
                     <a:ext uri="{A12FA001-AC4F-418D-AE19-62706E023703}">
                       <ahyp:hlinkClr xmlns:ahyp="http://schemas.microsoft.com/office/drawing/2018/hyperlinkcolor" val="tx"/>
@@ -8717,7 +8731,7 @@
           <a:bodyPr wrap="square" lIns="0" tIns="0" rIns="0" bIns="0" rtlCol="0" anchor="ctr"/>
           <a:lstStyle/>
           <a:p>
-            <a:pPr indent="0" marL="0">
+            <a:pPr marL="0" indent="0">
               <a:buNone/>
             </a:pPr>
             <a:r>
@@ -8756,7 +8770,7 @@
           <a:bodyPr wrap="square" lIns="0" tIns="0" rIns="0" bIns="0" rtlCol="0" anchor="ctr"/>
           <a:lstStyle/>
           <a:p>
-            <a:pPr indent="0" marL="0">
+            <a:pPr marL="0" indent="0">
               <a:buNone/>
             </a:pPr>
             <a:r>
@@ -8767,7 +8781,7 @@
                 <a:latin typeface="Calibri" pitchFamily="34" charset="0"/>
                 <a:ea typeface="Calibri" pitchFamily="34" charset="-122"/>
                 <a:cs typeface="Calibri" pitchFamily="34" charset="-120"/>
-                <a:hlinkClick r:id="rId2" invalidUrl="" action="" tgtFrame="" tooltip="" history="1" highlightClick="0" endSnd="0">
+                <a:hlinkClick r:id="rId4">
                   <a:extLst>
                     <a:ext uri="{A12FA001-AC4F-418D-AE19-62706E023703}">
                       <ahyp:hlinkClr xmlns:ahyp="http://schemas.microsoft.com/office/drawing/2018/hyperlinkcolor" val="tx"/>
@@ -8802,7 +8816,7 @@
           <a:bodyPr wrap="square" lIns="0" tIns="0" rIns="0" bIns="0" rtlCol="0" anchor="ctr"/>
           <a:lstStyle/>
           <a:p>
-            <a:pPr indent="0" marL="0">
+            <a:pPr marL="0" indent="0">
               <a:buNone/>
             </a:pPr>
             <a:r>
@@ -8841,7 +8855,7 @@
           <a:bodyPr wrap="square" lIns="0" tIns="0" rIns="0" bIns="0" rtlCol="0" anchor="ctr"/>
           <a:lstStyle/>
           <a:p>
-            <a:pPr indent="0" marL="0">
+            <a:pPr marL="0" indent="0">
               <a:buNone/>
             </a:pPr>
             <a:r>
@@ -8852,7 +8866,7 @@
                 <a:latin typeface="Calibri" pitchFamily="34" charset="0"/>
                 <a:ea typeface="Calibri" pitchFamily="34" charset="-122"/>
                 <a:cs typeface="Calibri" pitchFamily="34" charset="-120"/>
-                <a:hlinkClick r:id="rId3" invalidUrl="" action="" tgtFrame="" tooltip="" history="1" highlightClick="0" endSnd="0">
+                <a:hlinkClick r:id="rId5">
                   <a:extLst>
                     <a:ext uri="{A12FA001-AC4F-418D-AE19-62706E023703}">
                       <ahyp:hlinkClr xmlns:ahyp="http://schemas.microsoft.com/office/drawing/2018/hyperlinkcolor" val="tx"/>
@@ -8862,9 +8876,6 @@
               </a:rPr>
               <a:t>code</a:t>
             </a:r>
-            <a:pPr indent="0" marL="0">
-              <a:buNone/>
-            </a:pPr>
             <a:r>
               <a:rPr lang="en-US" sz="1200" dirty="0">
                 <a:solidFill>
@@ -8876,9 +8887,6 @@
               </a:rPr>
               <a:t>   ·   </a:t>
             </a:r>
-            <a:pPr indent="0" marL="0">
-              <a:buNone/>
-            </a:pPr>
             <a:r>
               <a:rPr lang="en-US" sz="1200" b="1" u="sng" dirty="0">
                 <a:solidFill>
@@ -8887,7 +8895,7 @@
                 <a:latin typeface="Calibri" pitchFamily="34" charset="0"/>
                 <a:ea typeface="Calibri" pitchFamily="34" charset="-122"/>
                 <a:cs typeface="Calibri" pitchFamily="34" charset="-120"/>
-                <a:hlinkClick r:id="rId4" invalidUrl="" action="" tgtFrame="" tooltip="" history="1" highlightClick="0" endSnd="0">
+                <a:hlinkClick r:id="rId6">
                   <a:extLst>
                     <a:ext uri="{A12FA001-AC4F-418D-AE19-62706E023703}">
                       <ahyp:hlinkClr xmlns:ahyp="http://schemas.microsoft.com/office/drawing/2018/hyperlinkcolor" val="tx"/>
@@ -8922,7 +8930,7 @@
           <a:bodyPr wrap="square" lIns="0" tIns="0" rIns="0" bIns="0" rtlCol="0" anchor="ctr"/>
           <a:lstStyle/>
           <a:p>
-            <a:pPr indent="0" marL="0">
+            <a:pPr marL="0" indent="0">
               <a:buNone/>
             </a:pPr>
             <a:r>
@@ -8961,7 +8969,7 @@
           <a:bodyPr wrap="square" lIns="0" tIns="0" rIns="0" bIns="0" rtlCol="0" anchor="ctr"/>
           <a:lstStyle/>
           <a:p>
-            <a:pPr indent="0" marL="0">
+            <a:pPr marL="0" indent="0">
               <a:buNone/>
             </a:pPr>
             <a:r>
@@ -8972,7 +8980,7 @@
                 <a:latin typeface="Calibri" pitchFamily="34" charset="0"/>
                 <a:ea typeface="Calibri" pitchFamily="34" charset="-122"/>
                 <a:cs typeface="Calibri" pitchFamily="34" charset="-120"/>
-                <a:hlinkClick r:id="rId5" invalidUrl="" action="" tgtFrame="" tooltip="" history="1" highlightClick="0" endSnd="0">
+                <a:hlinkClick r:id="rId7">
                   <a:extLst>
                     <a:ext uri="{A12FA001-AC4F-418D-AE19-62706E023703}">
                       <ahyp:hlinkClr xmlns:ahyp="http://schemas.microsoft.com/office/drawing/2018/hyperlinkcolor" val="tx"/>
@@ -8982,9 +8990,6 @@
               </a:rPr>
               <a:t>code</a:t>
             </a:r>
-            <a:pPr indent="0" marL="0">
-              <a:buNone/>
-            </a:pPr>
             <a:r>
               <a:rPr lang="en-US" sz="1200" dirty="0">
                 <a:solidFill>
@@ -8996,9 +9001,6 @@
               </a:rPr>
               <a:t>   ·   </a:t>
             </a:r>
-            <a:pPr indent="0" marL="0">
-              <a:buNone/>
-            </a:pPr>
             <a:r>
               <a:rPr lang="en-US" sz="1200" b="1" u="sng" dirty="0">
                 <a:solidFill>
@@ -9007,7 +9009,7 @@
                 <a:latin typeface="Calibri" pitchFamily="34" charset="0"/>
                 <a:ea typeface="Calibri" pitchFamily="34" charset="-122"/>
                 <a:cs typeface="Calibri" pitchFamily="34" charset="-120"/>
-                <a:hlinkClick r:id="rId6" invalidUrl="" action="" tgtFrame="" tooltip="" history="1" highlightClick="0" endSnd="0">
+                <a:hlinkClick r:id="rId8">
                   <a:extLst>
                     <a:ext uri="{A12FA001-AC4F-418D-AE19-62706E023703}">
                       <ahyp:hlinkClr xmlns:ahyp="http://schemas.microsoft.com/office/drawing/2018/hyperlinkcolor" val="tx"/>
@@ -9042,7 +9044,7 @@
           <a:bodyPr wrap="square" lIns="0" tIns="0" rIns="0" bIns="0" rtlCol="0" anchor="ctr"/>
           <a:lstStyle/>
           <a:p>
-            <a:pPr indent="0" marL="0">
+            <a:pPr marL="0" indent="0">
               <a:buNone/>
             </a:pPr>
             <a:r>
@@ -9081,7 +9083,7 @@
           <a:bodyPr wrap="square" lIns="0" tIns="0" rIns="0" bIns="0" rtlCol="0" anchor="ctr"/>
           <a:lstStyle/>
           <a:p>
-            <a:pPr indent="0" marL="0">
+            <a:pPr marL="0" indent="0">
               <a:buNone/>
             </a:pPr>
             <a:r>
@@ -9092,7 +9094,7 @@
                 <a:latin typeface="Calibri" pitchFamily="34" charset="0"/>
                 <a:ea typeface="Calibri" pitchFamily="34" charset="-122"/>
                 <a:cs typeface="Calibri" pitchFamily="34" charset="-120"/>
-                <a:hlinkClick r:id="rId7" invalidUrl="" action="" tgtFrame="" tooltip="" history="1" highlightClick="0" endSnd="0">
+                <a:hlinkClick r:id="rId9">
                   <a:extLst>
                     <a:ext uri="{A12FA001-AC4F-418D-AE19-62706E023703}">
                       <ahyp:hlinkClr xmlns:ahyp="http://schemas.microsoft.com/office/drawing/2018/hyperlinkcolor" val="tx"/>
@@ -9127,7 +9129,7 @@
           <a:bodyPr wrap="square" lIns="0" tIns="0" rIns="0" bIns="0" rtlCol="0" anchor="ctr"/>
           <a:lstStyle/>
           <a:p>
-            <a:pPr indent="0" marL="0">
+            <a:pPr marL="0" indent="0">
               <a:buNone/>
             </a:pPr>
             <a:r>
@@ -9191,7 +9193,7 @@
           <a:bodyPr wrap="square" lIns="0" tIns="0" rIns="0" bIns="0" rtlCol="0" anchor="ctr"/>
           <a:lstStyle/>
           <a:p>
-            <a:pPr indent="0" marL="0">
+            <a:pPr marL="0" indent="0">
               <a:buNone/>
             </a:pPr>
             <a:r>
@@ -9235,13 +9237,20 @@
             <a:prstDash val="solid"/>
           </a:ln>
           <a:effectLst>
-            <a:outerShdw sx="100000" sy="100000" kx="0" ky="0" algn="bl" rotWithShape="0" blurRad="127000" dist="25400" dir="5400000">
+            <a:outerShdw blurRad="127000" dist="25400" dir="5400000" algn="bl" rotWithShape="0">
               <a:srgbClr val="9AAAC4">
                 <a:alpha val="30000"/>
               </a:srgbClr>
             </a:outerShdw>
           </a:effectLst>
         </p:spPr>
+        <p:txBody>
+          <a:bodyPr/>
+          <a:lstStyle/>
+          <a:p>
+            <a:endParaRPr lang="en-US"/>
+          </a:p>
+        </p:txBody>
       </p:sp>
       <p:sp>
         <p:nvSpPr>
@@ -9264,7 +9273,7 @@
           <a:bodyPr wrap="square" lIns="0" tIns="0" rIns="0" bIns="0" rtlCol="0" anchor="ctr"/>
           <a:lstStyle/>
           <a:p>
-            <a:pPr indent="0" marL="0">
+            <a:pPr marL="0" indent="0">
               <a:lnSpc>
                 <a:spcPts val="4400"/>
               </a:lnSpc>
@@ -9284,7 +9293,7 @@
             <a:endParaRPr lang="en-US" sz="2900" dirty="0"/>
           </a:p>
           <a:p>
-            <a:pPr indent="0" marL="0">
+            <a:pPr marL="0" indent="0">
               <a:lnSpc>
                 <a:spcPts val="4400"/>
               </a:lnSpc>
@@ -9326,7 +9335,7 @@
           <a:bodyPr wrap="square" lIns="0" tIns="0" rIns="0" bIns="0" rtlCol="0" anchor="ctr"/>
           <a:lstStyle/>
           <a:p>
-            <a:pPr indent="0" marL="0">
+            <a:pPr marL="0" indent="0">
               <a:buNone/>
             </a:pPr>
             <a:r>
@@ -9424,6 +9433,7 @@
         <a:solidFill>
           <a:srgbClr val="12294F"/>
         </a:solidFill>
+        <a:effectLst/>
       </p:bgPr>
     </p:bg>
     <p:spTree>
@@ -9461,7 +9471,7 @@
           <a:bodyPr wrap="square" lIns="0" tIns="0" rIns="0" bIns="0" rtlCol="0" anchor="ctr"/>
           <a:lstStyle/>
           <a:p>
-            <a:pPr indent="0" marL="0">
+            <a:pPr marL="0" indent="0">
               <a:buNone/>
             </a:pPr>
             <a:r>
@@ -9500,7 +9510,7 @@
           <a:bodyPr wrap="square" lIns="0" tIns="0" rIns="0" bIns="0" rtlCol="0" anchor="ctr"/>
           <a:lstStyle/>
           <a:p>
-            <a:pPr indent="0" marL="0">
+            <a:pPr marL="0" indent="0">
               <a:buNone/>
             </a:pPr>
             <a:r>
@@ -9544,6 +9554,13 @@
             <a:prstDash val="solid"/>
           </a:ln>
         </p:spPr>
+        <p:txBody>
+          <a:bodyPr/>
+          <a:lstStyle/>
+          <a:p>
+            <a:endParaRPr lang="en-US"/>
+          </a:p>
+        </p:txBody>
       </p:sp>
       <p:sp>
         <p:nvSpPr>
@@ -9566,7 +9583,7 @@
           <a:bodyPr wrap="square" lIns="0" tIns="0" rIns="0" bIns="0" rtlCol="0" anchor="ctr"/>
           <a:lstStyle/>
           <a:p>
-            <a:pPr algn="ctr" indent="0" marL="0">
+            <a:pPr marL="0" indent="0" algn="ctr">
               <a:buNone/>
             </a:pPr>
             <a:r>
@@ -9577,7 +9594,7 @@
                 <a:latin typeface="Courier New" pitchFamily="34" charset="0"/>
                 <a:ea typeface="Courier New" pitchFamily="34" charset="-122"/>
                 <a:cs typeface="Courier New" pitchFamily="34" charset="-120"/>
-                <a:hlinkClick r:id="rId1" invalidUrl="" action="" tgtFrame="" tooltip="" history="1" highlightClick="0" endSnd="0">
+                <a:hlinkClick r:id="rId3">
                   <a:extLst>
                     <a:ext uri="{A12FA001-AC4F-418D-AE19-62706E023703}">
                       <ahyp:hlinkClr xmlns:ahyp="http://schemas.microsoft.com/office/drawing/2018/hyperlinkcolor" val="tx"/>
@@ -9617,6 +9634,13 @@
             <a:prstDash val="solid"/>
           </a:ln>
         </p:spPr>
+        <p:txBody>
+          <a:bodyPr/>
+          <a:lstStyle/>
+          <a:p>
+            <a:endParaRPr lang="en-US"/>
+          </a:p>
+        </p:txBody>
       </p:sp>
       <p:sp>
         <p:nvSpPr>
@@ -9639,7 +9663,7 @@
           <a:bodyPr wrap="square" lIns="0" tIns="0" rIns="0" bIns="0" rtlCol="0" anchor="ctr"/>
           <a:lstStyle/>
           <a:p>
-            <a:pPr indent="0" marL="0">
+            <a:pPr marL="0" indent="0">
               <a:buNone/>
             </a:pPr>
             <a:r>
@@ -9678,7 +9702,7 @@
           <a:bodyPr wrap="square" lIns="0" tIns="0" rIns="0" bIns="0" rtlCol="0" anchor="ctr"/>
           <a:lstStyle/>
           <a:p>
-            <a:pPr indent="0" marL="0">
+            <a:pPr marL="0" indent="0">
               <a:buNone/>
             </a:pPr>
             <a:r>
@@ -9722,6 +9746,13 @@
             <a:prstDash val="solid"/>
           </a:ln>
         </p:spPr>
+        <p:txBody>
+          <a:bodyPr/>
+          <a:lstStyle/>
+          <a:p>
+            <a:endParaRPr lang="en-US"/>
+          </a:p>
+        </p:txBody>
       </p:sp>
       <p:sp>
         <p:nvSpPr>
@@ -9744,7 +9775,7 @@
           <a:bodyPr wrap="square" lIns="0" tIns="0" rIns="0" bIns="0" rtlCol="0" anchor="ctr"/>
           <a:lstStyle/>
           <a:p>
-            <a:pPr indent="0" marL="0">
+            <a:pPr marL="0" indent="0">
               <a:buNone/>
             </a:pPr>
             <a:r>
@@ -9783,7 +9814,7 @@
           <a:bodyPr wrap="square" lIns="0" tIns="0" rIns="0" bIns="0" rtlCol="0" anchor="ctr"/>
           <a:lstStyle/>
           <a:p>
-            <a:pPr indent="0" marL="0">
+            <a:pPr marL="0" indent="0">
               <a:buNone/>
             </a:pPr>
             <a:r>
@@ -9827,6 +9858,13 @@
             <a:prstDash val="solid"/>
           </a:ln>
         </p:spPr>
+        <p:txBody>
+          <a:bodyPr/>
+          <a:lstStyle/>
+          <a:p>
+            <a:endParaRPr lang="en-US"/>
+          </a:p>
+        </p:txBody>
       </p:sp>
       <p:sp>
         <p:nvSpPr>
@@ -9849,7 +9887,7 @@
           <a:bodyPr wrap="square" lIns="0" tIns="0" rIns="0" bIns="0" rtlCol="0" anchor="ctr"/>
           <a:lstStyle/>
           <a:p>
-            <a:pPr indent="0" marL="0">
+            <a:pPr marL="0" indent="0">
               <a:buNone/>
             </a:pPr>
             <a:r>
@@ -9888,7 +9926,7 @@
           <a:bodyPr wrap="square" lIns="0" tIns="0" rIns="0" bIns="0" rtlCol="0" anchor="ctr"/>
           <a:lstStyle/>
           <a:p>
-            <a:pPr indent="0" marL="0">
+            <a:pPr marL="0" indent="0">
               <a:buNone/>
             </a:pPr>
             <a:r>
@@ -9927,7 +9965,7 @@
           <a:bodyPr wrap="square" lIns="0" tIns="0" rIns="0" bIns="0" rtlCol="0" anchor="ctr"/>
           <a:lstStyle/>
           <a:p>
-            <a:pPr indent="0" marL="0">
+            <a:pPr marL="0" indent="0">
               <a:buNone/>
             </a:pPr>
             <a:r>
@@ -9991,7 +10029,7 @@
           <a:bodyPr wrap="square" lIns="0" tIns="0" rIns="0" bIns="0" rtlCol="0" anchor="ctr"/>
           <a:lstStyle/>
           <a:p>
-            <a:pPr indent="0" marL="0">
+            <a:pPr marL="0" indent="0">
               <a:buNone/>
             </a:pPr>
             <a:r>
@@ -10030,7 +10068,7 @@
           <a:bodyPr wrap="square" lIns="0" tIns="0" rIns="0" bIns="0" rtlCol="0" anchor="ctr"/>
           <a:lstStyle/>
           <a:p>
-            <a:pPr indent="0" marL="0">
+            <a:pPr marL="0" indent="0">
               <a:buNone/>
             </a:pPr>
             <a:r>
@@ -10074,13 +10112,20 @@
             <a:prstDash val="solid"/>
           </a:ln>
           <a:effectLst>
-            <a:outerShdw sx="100000" sy="100000" kx="0" ky="0" algn="bl" rotWithShape="0" blurRad="127000" dist="25400" dir="5400000">
+            <a:outerShdw blurRad="127000" dist="25400" dir="5400000" algn="bl" rotWithShape="0">
               <a:srgbClr val="9AAAC4">
                 <a:alpha val="30000"/>
               </a:srgbClr>
             </a:outerShdw>
           </a:effectLst>
         </p:spPr>
+        <p:txBody>
+          <a:bodyPr/>
+          <a:lstStyle/>
+          <a:p>
+            <a:endParaRPr lang="en-US"/>
+          </a:p>
+        </p:txBody>
       </p:sp>
       <p:sp>
         <p:nvSpPr>
@@ -10106,6 +10151,13 @@
             <a:prstDash val="solid"/>
           </a:ln>
         </p:spPr>
+        <p:txBody>
+          <a:bodyPr/>
+          <a:lstStyle/>
+          <a:p>
+            <a:endParaRPr lang="en-US"/>
+          </a:p>
+        </p:txBody>
       </p:sp>
       <p:sp>
         <p:nvSpPr>
@@ -10128,7 +10180,7 @@
           <a:bodyPr wrap="square" lIns="0" tIns="0" rIns="0" bIns="0" rtlCol="0" anchor="ctr"/>
           <a:lstStyle/>
           <a:p>
-            <a:pPr algn="ctr" indent="0" marL="0">
+            <a:pPr marL="0" indent="0" algn="ctr">
               <a:buNone/>
             </a:pPr>
             <a:r>
@@ -10167,7 +10219,7 @@
           <a:bodyPr wrap="square" lIns="0" tIns="0" rIns="0" bIns="0" rtlCol="0" anchor="ctr"/>
           <a:lstStyle/>
           <a:p>
-            <a:pPr indent="0" marL="0">
+            <a:pPr marL="0" indent="0">
               <a:buNone/>
             </a:pPr>
             <a:r>
@@ -10206,7 +10258,7 @@
           <a:bodyPr wrap="square" lIns="0" tIns="0" rIns="0" bIns="0" rtlCol="0" anchor="ctr"/>
           <a:lstStyle/>
           <a:p>
-            <a:pPr indent="0" marL="0">
+            <a:pPr marL="0" indent="0">
               <a:buNone/>
             </a:pPr>
             <a:r>
@@ -10245,7 +10297,7 @@
           <a:bodyPr wrap="square" lIns="0" tIns="0" rIns="0" bIns="0" rtlCol="0" anchor="ctr"/>
           <a:lstStyle/>
           <a:p>
-            <a:pPr indent="0" marL="0">
+            <a:pPr marL="0" indent="0">
               <a:buNone/>
             </a:pPr>
             <a:r>
@@ -10289,13 +10341,20 @@
             <a:prstDash val="solid"/>
           </a:ln>
           <a:effectLst>
-            <a:outerShdw sx="100000" sy="100000" kx="0" ky="0" algn="bl" rotWithShape="0" blurRad="127000" dist="25400" dir="5400000">
+            <a:outerShdw blurRad="127000" dist="25400" dir="5400000" algn="bl" rotWithShape="0">
               <a:srgbClr val="9AAAC4">
                 <a:alpha val="30000"/>
               </a:srgbClr>
             </a:outerShdw>
           </a:effectLst>
         </p:spPr>
+        <p:txBody>
+          <a:bodyPr/>
+          <a:lstStyle/>
+          <a:p>
+            <a:endParaRPr lang="en-US"/>
+          </a:p>
+        </p:txBody>
       </p:sp>
       <p:sp>
         <p:nvSpPr>
@@ -10321,6 +10380,13 @@
             <a:prstDash val="solid"/>
           </a:ln>
         </p:spPr>
+        <p:txBody>
+          <a:bodyPr/>
+          <a:lstStyle/>
+          <a:p>
+            <a:endParaRPr lang="en-US"/>
+          </a:p>
+        </p:txBody>
       </p:sp>
       <p:sp>
         <p:nvSpPr>
@@ -10343,7 +10409,7 @@
           <a:bodyPr wrap="square" lIns="0" tIns="0" rIns="0" bIns="0" rtlCol="0" anchor="ctr"/>
           <a:lstStyle/>
           <a:p>
-            <a:pPr algn="ctr" indent="0" marL="0">
+            <a:pPr marL="0" indent="0" algn="ctr">
               <a:buNone/>
             </a:pPr>
             <a:r>
@@ -10382,7 +10448,7 @@
           <a:bodyPr wrap="square" lIns="0" tIns="0" rIns="0" bIns="0" rtlCol="0" anchor="ctr"/>
           <a:lstStyle/>
           <a:p>
-            <a:pPr indent="0" marL="0">
+            <a:pPr marL="0" indent="0">
               <a:buNone/>
             </a:pPr>
             <a:r>
@@ -10421,7 +10487,7 @@
           <a:bodyPr wrap="square" lIns="0" tIns="0" rIns="0" bIns="0" rtlCol="0" anchor="ctr"/>
           <a:lstStyle/>
           <a:p>
-            <a:pPr indent="0" marL="0">
+            <a:pPr marL="0" indent="0">
               <a:buNone/>
             </a:pPr>
             <a:r>
@@ -10460,7 +10526,7 @@
           <a:bodyPr wrap="square" lIns="0" tIns="0" rIns="0" bIns="0" rtlCol="0" anchor="ctr"/>
           <a:lstStyle/>
           <a:p>
-            <a:pPr indent="0" marL="0">
+            <a:pPr marL="0" indent="0">
               <a:buNone/>
             </a:pPr>
             <a:r>
@@ -10504,13 +10570,20 @@
             <a:prstDash val="solid"/>
           </a:ln>
           <a:effectLst>
-            <a:outerShdw sx="100000" sy="100000" kx="0" ky="0" algn="bl" rotWithShape="0" blurRad="127000" dist="25400" dir="5400000">
+            <a:outerShdw blurRad="127000" dist="25400" dir="5400000" algn="bl" rotWithShape="0">
               <a:srgbClr val="9AAAC4">
                 <a:alpha val="30000"/>
               </a:srgbClr>
             </a:outerShdw>
           </a:effectLst>
         </p:spPr>
+        <p:txBody>
+          <a:bodyPr/>
+          <a:lstStyle/>
+          <a:p>
+            <a:endParaRPr lang="en-US"/>
+          </a:p>
+        </p:txBody>
       </p:sp>
       <p:sp>
         <p:nvSpPr>
@@ -10536,6 +10609,13 @@
             <a:prstDash val="solid"/>
           </a:ln>
         </p:spPr>
+        <p:txBody>
+          <a:bodyPr/>
+          <a:lstStyle/>
+          <a:p>
+            <a:endParaRPr lang="en-US"/>
+          </a:p>
+        </p:txBody>
       </p:sp>
       <p:sp>
         <p:nvSpPr>
@@ -10558,7 +10638,7 @@
           <a:bodyPr wrap="square" lIns="0" tIns="0" rIns="0" bIns="0" rtlCol="0" anchor="ctr"/>
           <a:lstStyle/>
           <a:p>
-            <a:pPr algn="ctr" indent="0" marL="0">
+            <a:pPr marL="0" indent="0" algn="ctr">
               <a:buNone/>
             </a:pPr>
             <a:r>
@@ -10597,7 +10677,7 @@
           <a:bodyPr wrap="square" lIns="0" tIns="0" rIns="0" bIns="0" rtlCol="0" anchor="ctr"/>
           <a:lstStyle/>
           <a:p>
-            <a:pPr indent="0" marL="0">
+            <a:pPr marL="0" indent="0">
               <a:buNone/>
             </a:pPr>
             <a:r>
@@ -10636,7 +10716,7 @@
           <a:bodyPr wrap="square" lIns="0" tIns="0" rIns="0" bIns="0" rtlCol="0" anchor="ctr"/>
           <a:lstStyle/>
           <a:p>
-            <a:pPr indent="0" marL="0">
+            <a:pPr marL="0" indent="0">
               <a:buNone/>
             </a:pPr>
             <a:r>
@@ -10675,7 +10755,7 @@
           <a:bodyPr wrap="square" lIns="0" tIns="0" rIns="0" bIns="0" rtlCol="0" anchor="ctr"/>
           <a:lstStyle/>
           <a:p>
-            <a:pPr indent="0" marL="0">
+            <a:pPr marL="0" indent="0">
               <a:buNone/>
             </a:pPr>
             <a:r>
@@ -10719,13 +10799,20 @@
             <a:prstDash val="solid"/>
           </a:ln>
           <a:effectLst>
-            <a:outerShdw sx="100000" sy="100000" kx="0" ky="0" algn="bl" rotWithShape="0" blurRad="127000" dist="25400" dir="5400000">
+            <a:outerShdw blurRad="127000" dist="25400" dir="5400000" algn="bl" rotWithShape="0">
               <a:srgbClr val="9AAAC4">
                 <a:alpha val="30000"/>
               </a:srgbClr>
             </a:outerShdw>
           </a:effectLst>
         </p:spPr>
+        <p:txBody>
+          <a:bodyPr/>
+          <a:lstStyle/>
+          <a:p>
+            <a:endParaRPr lang="en-US"/>
+          </a:p>
+        </p:txBody>
       </p:sp>
       <p:sp>
         <p:nvSpPr>
@@ -10751,6 +10838,13 @@
             <a:prstDash val="solid"/>
           </a:ln>
         </p:spPr>
+        <p:txBody>
+          <a:bodyPr/>
+          <a:lstStyle/>
+          <a:p>
+            <a:endParaRPr lang="en-US"/>
+          </a:p>
+        </p:txBody>
       </p:sp>
       <p:sp>
         <p:nvSpPr>
@@ -10773,7 +10867,7 @@
           <a:bodyPr wrap="square" lIns="0" tIns="0" rIns="0" bIns="0" rtlCol="0" anchor="ctr"/>
           <a:lstStyle/>
           <a:p>
-            <a:pPr algn="ctr" indent="0" marL="0">
+            <a:pPr marL="0" indent="0" algn="ctr">
               <a:buNone/>
             </a:pPr>
             <a:r>
@@ -10812,7 +10906,7 @@
           <a:bodyPr wrap="square" lIns="0" tIns="0" rIns="0" bIns="0" rtlCol="0" anchor="ctr"/>
           <a:lstStyle/>
           <a:p>
-            <a:pPr indent="0" marL="0">
+            <a:pPr marL="0" indent="0">
               <a:buNone/>
             </a:pPr>
             <a:r>
@@ -10851,7 +10945,7 @@
           <a:bodyPr wrap="square" lIns="0" tIns="0" rIns="0" bIns="0" rtlCol="0" anchor="ctr"/>
           <a:lstStyle/>
           <a:p>
-            <a:pPr indent="0" marL="0">
+            <a:pPr marL="0" indent="0">
               <a:buNone/>
             </a:pPr>
             <a:r>
@@ -10890,7 +10984,7 @@
           <a:bodyPr wrap="square" lIns="0" tIns="0" rIns="0" bIns="0" rtlCol="0" anchor="ctr"/>
           <a:lstStyle/>
           <a:p>
-            <a:pPr indent="0" marL="0">
+            <a:pPr marL="0" indent="0">
               <a:buNone/>
             </a:pPr>
             <a:r>
@@ -10957,6 +11051,13 @@
             <a:prstDash val="solid"/>
           </a:ln>
         </p:spPr>
+        <p:txBody>
+          <a:bodyPr/>
+          <a:lstStyle/>
+          <a:p>
+            <a:endParaRPr lang="en-US"/>
+          </a:p>
+        </p:txBody>
       </p:sp>
       <p:sp>
         <p:nvSpPr>
@@ -10979,7 +11080,7 @@
           <a:bodyPr wrap="square" lIns="0" tIns="0" rIns="0" bIns="0" rtlCol="0" anchor="ctr"/>
           <a:lstStyle/>
           <a:p>
-            <a:pPr algn="ctr" indent="0" marL="0">
+            <a:pPr marL="0" indent="0" algn="ctr">
               <a:buNone/>
             </a:pPr>
             <a:r>
@@ -11018,7 +11119,7 @@
           <a:bodyPr wrap="square" lIns="0" tIns="0" rIns="0" bIns="0" rtlCol="0" anchor="ctr"/>
           <a:lstStyle/>
           <a:p>
-            <a:pPr indent="0" marL="0">
+            <a:pPr marL="0" indent="0">
               <a:buNone/>
             </a:pPr>
             <a:r>
@@ -11057,7 +11158,7 @@
           <a:bodyPr wrap="square" lIns="0" tIns="0" rIns="0" bIns="0" rtlCol="0" anchor="ctr"/>
           <a:lstStyle/>
           <a:p>
-            <a:pPr indent="0" marL="0">
+            <a:pPr marL="0" indent="0">
               <a:buNone/>
             </a:pPr>
             <a:r>
@@ -11101,13 +11202,20 @@
             <a:prstDash val="solid"/>
           </a:ln>
           <a:effectLst>
-            <a:outerShdw sx="100000" sy="100000" kx="0" ky="0" algn="bl" rotWithShape="0" blurRad="127000" dist="25400" dir="5400000">
+            <a:outerShdw blurRad="127000" dist="25400" dir="5400000" algn="bl" rotWithShape="0">
               <a:srgbClr val="9AAAC4">
                 <a:alpha val="30000"/>
               </a:srgbClr>
             </a:outerShdw>
           </a:effectLst>
         </p:spPr>
+        <p:txBody>
+          <a:bodyPr/>
+          <a:lstStyle/>
+          <a:p>
+            <a:endParaRPr lang="en-US"/>
+          </a:p>
+        </p:txBody>
       </p:sp>
       <p:sp>
         <p:nvSpPr>
@@ -11130,11 +11238,11 @@
           <a:bodyPr wrap="square" lIns="0" tIns="0" rIns="0" bIns="0" rtlCol="0" anchor="ctr"/>
           <a:lstStyle/>
           <a:p>
-            <a:pPr indent="0" marL="0">
-              <a:buNone/>
-            </a:pPr>
-            <a:r>
-              <a:rPr lang="en-US" sz="1050" b="1" spc="150" kern="0" dirty="0">
+            <a:pPr marL="0" indent="0">
+              <a:buNone/>
+            </a:pPr>
+            <a:r>
+              <a:rPr lang="en-US" sz="1050" b="1" kern="0" spc="150" dirty="0">
                 <a:solidFill>
                   <a:srgbClr val="C07A22"/>
                 </a:solidFill>
@@ -11169,7 +11277,7 @@
           <a:bodyPr wrap="square" lIns="0" tIns="0" rIns="0" bIns="0" rtlCol="0" anchor="t"/>
           <a:lstStyle/>
           <a:p>
-            <a:pPr indent="0" marL="0">
+            <a:pPr marL="0" indent="0">
               <a:buNone/>
             </a:pPr>
             <a:r>
@@ -11213,13 +11321,20 @@
             <a:prstDash val="solid"/>
           </a:ln>
           <a:effectLst>
-            <a:outerShdw sx="100000" sy="100000" kx="0" ky="0" algn="bl" rotWithShape="0" blurRad="127000" dist="25400" dir="5400000">
+            <a:outerShdw blurRad="127000" dist="25400" dir="5400000" algn="bl" rotWithShape="0">
               <a:srgbClr val="9AAAC4">
                 <a:alpha val="30000"/>
               </a:srgbClr>
             </a:outerShdw>
           </a:effectLst>
         </p:spPr>
+        <p:txBody>
+          <a:bodyPr/>
+          <a:lstStyle/>
+          <a:p>
+            <a:endParaRPr lang="en-US"/>
+          </a:p>
+        </p:txBody>
       </p:sp>
       <p:sp>
         <p:nvSpPr>
@@ -11242,11 +11357,11 @@
           <a:bodyPr wrap="square" lIns="0" tIns="0" rIns="0" bIns="0" rtlCol="0" anchor="ctr"/>
           <a:lstStyle/>
           <a:p>
-            <a:pPr indent="0" marL="0">
-              <a:buNone/>
-            </a:pPr>
-            <a:r>
-              <a:rPr lang="en-US" sz="1050" b="1" spc="150" kern="0" dirty="0">
+            <a:pPr marL="0" indent="0">
+              <a:buNone/>
+            </a:pPr>
+            <a:r>
+              <a:rPr lang="en-US" sz="1050" b="1" kern="0" spc="150" dirty="0">
                 <a:solidFill>
                   <a:srgbClr val="C07A22"/>
                 </a:solidFill>
@@ -11281,7 +11396,7 @@
           <a:bodyPr wrap="square" lIns="0" tIns="0" rIns="0" bIns="0" rtlCol="0" anchor="t"/>
           <a:lstStyle/>
           <a:p>
-            <a:pPr indent="0" marL="0">
+            <a:pPr marL="0" indent="0">
               <a:buNone/>
             </a:pPr>
             <a:r>
@@ -11325,13 +11440,20 @@
             <a:prstDash val="solid"/>
           </a:ln>
           <a:effectLst>
-            <a:outerShdw sx="100000" sy="100000" kx="0" ky="0" algn="bl" rotWithShape="0" blurRad="127000" dist="25400" dir="5400000">
+            <a:outerShdw blurRad="127000" dist="25400" dir="5400000" algn="bl" rotWithShape="0">
               <a:srgbClr val="9AAAC4">
                 <a:alpha val="30000"/>
               </a:srgbClr>
             </a:outerShdw>
           </a:effectLst>
         </p:spPr>
+        <p:txBody>
+          <a:bodyPr/>
+          <a:lstStyle/>
+          <a:p>
+            <a:endParaRPr lang="en-US"/>
+          </a:p>
+        </p:txBody>
       </p:sp>
       <p:sp>
         <p:nvSpPr>
@@ -11354,11 +11476,11 @@
           <a:bodyPr wrap="square" lIns="0" tIns="0" rIns="0" bIns="0" rtlCol="0" anchor="ctr"/>
           <a:lstStyle/>
           <a:p>
-            <a:pPr indent="0" marL="0">
-              <a:buNone/>
-            </a:pPr>
-            <a:r>
-              <a:rPr lang="en-US" sz="1050" b="1" spc="150" kern="0" dirty="0">
+            <a:pPr marL="0" indent="0">
+              <a:buNone/>
+            </a:pPr>
+            <a:r>
+              <a:rPr lang="en-US" sz="1050" b="1" kern="0" spc="150" dirty="0">
                 <a:solidFill>
                   <a:srgbClr val="C07A22"/>
                 </a:solidFill>
@@ -11393,7 +11515,7 @@
           <a:bodyPr wrap="square" lIns="0" tIns="0" rIns="0" bIns="0" rtlCol="0" anchor="t"/>
           <a:lstStyle/>
           <a:p>
-            <a:pPr indent="0" marL="0">
+            <a:pPr marL="0" indent="0">
               <a:buNone/>
             </a:pPr>
             <a:r>
@@ -11432,7 +11554,7 @@
           <a:bodyPr wrap="square" lIns="0" tIns="0" rIns="0" bIns="0" rtlCol="0" anchor="ctr"/>
           <a:lstStyle/>
           <a:p>
-            <a:pPr indent="0" marL="0">
+            <a:pPr marL="0" indent="0">
               <a:buNone/>
             </a:pPr>
             <a:r>
@@ -11476,13 +11598,20 @@
             <a:prstDash val="solid"/>
           </a:ln>
           <a:effectLst>
-            <a:outerShdw sx="100000" sy="100000" kx="0" ky="0" algn="bl" rotWithShape="0" blurRad="127000" dist="25400" dir="5400000">
+            <a:outerShdw blurRad="127000" dist="25400" dir="5400000" algn="bl" rotWithShape="0">
               <a:srgbClr val="9AAAC4">
                 <a:alpha val="30000"/>
               </a:srgbClr>
             </a:outerShdw>
           </a:effectLst>
         </p:spPr>
+        <p:txBody>
+          <a:bodyPr/>
+          <a:lstStyle/>
+          <a:p>
+            <a:endParaRPr lang="en-US"/>
+          </a:p>
+        </p:txBody>
       </p:sp>
       <p:sp>
         <p:nvSpPr>
@@ -11505,7 +11634,7 @@
           <a:bodyPr wrap="square" lIns="0" tIns="0" rIns="0" bIns="0" rtlCol="0" anchor="ctr"/>
           <a:lstStyle/>
           <a:p>
-            <a:pPr indent="0" marL="0">
+            <a:pPr marL="0" indent="0">
               <a:buNone/>
             </a:pPr>
             <a:r>
@@ -11519,9 +11648,6 @@
               </a:rPr>
               <a:t>Code  </a:t>
             </a:r>
-            <a:pPr indent="0" marL="0">
-              <a:buNone/>
-            </a:pPr>
             <a:r>
               <a:rPr lang="en-US" sz="1050" u="sng" dirty="0">
                 <a:solidFill>
@@ -11530,7 +11656,7 @@
                 <a:latin typeface="Courier New" pitchFamily="34" charset="0"/>
                 <a:ea typeface="Courier New" pitchFamily="34" charset="-122"/>
                 <a:cs typeface="Courier New" pitchFamily="34" charset="-120"/>
-                <a:hlinkClick r:id="rId1" invalidUrl="" action="" tgtFrame="" tooltip="" history="1" highlightClick="0" endSnd="0">
+                <a:hlinkClick r:id="rId3">
                   <a:extLst>
                     <a:ext uri="{A12FA001-AC4F-418D-AE19-62706E023703}">
                       <ahyp:hlinkClr xmlns:ahyp="http://schemas.microsoft.com/office/drawing/2018/hyperlinkcolor" val="tx"/>
@@ -11565,7 +11691,7 @@
           <a:bodyPr wrap="square" lIns="0" tIns="0" rIns="0" bIns="0" rtlCol="0" anchor="ctr"/>
           <a:lstStyle/>
           <a:p>
-            <a:pPr indent="0" marL="0">
+            <a:pPr marL="0" indent="0">
               <a:buNone/>
             </a:pPr>
             <a:r>
@@ -11632,6 +11758,13 @@
             <a:prstDash val="solid"/>
           </a:ln>
         </p:spPr>
+        <p:txBody>
+          <a:bodyPr/>
+          <a:lstStyle/>
+          <a:p>
+            <a:endParaRPr lang="en-US"/>
+          </a:p>
+        </p:txBody>
       </p:sp>
       <p:sp>
         <p:nvSpPr>
@@ -11654,7 +11787,7 @@
           <a:bodyPr wrap="square" lIns="0" tIns="0" rIns="0" bIns="0" rtlCol="0" anchor="ctr"/>
           <a:lstStyle/>
           <a:p>
-            <a:pPr algn="ctr" indent="0" marL="0">
+            <a:pPr marL="0" indent="0" algn="ctr">
               <a:buNone/>
             </a:pPr>
             <a:r>
@@ -11693,7 +11826,7 @@
           <a:bodyPr wrap="square" lIns="0" tIns="0" rIns="0" bIns="0" rtlCol="0" anchor="ctr"/>
           <a:lstStyle/>
           <a:p>
-            <a:pPr indent="0" marL="0">
+            <a:pPr marL="0" indent="0">
               <a:buNone/>
             </a:pPr>
             <a:r>
@@ -11732,7 +11865,7 @@
           <a:bodyPr wrap="square" lIns="0" tIns="0" rIns="0" bIns="0" rtlCol="0" anchor="ctr"/>
           <a:lstStyle/>
           <a:p>
-            <a:pPr indent="0" marL="0">
+            <a:pPr marL="0" indent="0">
               <a:buNone/>
             </a:pPr>
             <a:r>
@@ -11776,13 +11909,20 @@
             <a:prstDash val="solid"/>
           </a:ln>
           <a:effectLst>
-            <a:outerShdw sx="100000" sy="100000" kx="0" ky="0" algn="bl" rotWithShape="0" blurRad="127000" dist="25400" dir="5400000">
+            <a:outerShdw blurRad="127000" dist="25400" dir="5400000" algn="bl" rotWithShape="0">
               <a:srgbClr val="9AAAC4">
                 <a:alpha val="30000"/>
               </a:srgbClr>
             </a:outerShdw>
           </a:effectLst>
         </p:spPr>
+        <p:txBody>
+          <a:bodyPr/>
+          <a:lstStyle/>
+          <a:p>
+            <a:endParaRPr lang="en-US"/>
+          </a:p>
+        </p:txBody>
       </p:sp>
       <p:sp>
         <p:nvSpPr>
@@ -11805,11 +11945,11 @@
           <a:bodyPr wrap="square" lIns="0" tIns="0" rIns="0" bIns="0" rtlCol="0" anchor="ctr"/>
           <a:lstStyle/>
           <a:p>
-            <a:pPr indent="0" marL="0">
-              <a:buNone/>
-            </a:pPr>
-            <a:r>
-              <a:rPr lang="en-US" sz="1050" b="1" spc="150" kern="0" dirty="0">
+            <a:pPr marL="0" indent="0">
+              <a:buNone/>
+            </a:pPr>
+            <a:r>
+              <a:rPr lang="en-US" sz="1050" b="1" kern="0" spc="150" dirty="0">
                 <a:solidFill>
                   <a:srgbClr val="C07A22"/>
                 </a:solidFill>
@@ -11844,7 +11984,7 @@
           <a:bodyPr wrap="square" lIns="0" tIns="0" rIns="0" bIns="0" rtlCol="0" anchor="t"/>
           <a:lstStyle/>
           <a:p>
-            <a:pPr indent="0" marL="0">
+            <a:pPr marL="0" indent="0">
               <a:buNone/>
             </a:pPr>
             <a:r>
@@ -11888,13 +12028,20 @@
             <a:prstDash val="solid"/>
           </a:ln>
           <a:effectLst>
-            <a:outerShdw sx="100000" sy="100000" kx="0" ky="0" algn="bl" rotWithShape="0" blurRad="127000" dist="25400" dir="5400000">
+            <a:outerShdw blurRad="127000" dist="25400" dir="5400000" algn="bl" rotWithShape="0">
               <a:srgbClr val="9AAAC4">
                 <a:alpha val="30000"/>
               </a:srgbClr>
             </a:outerShdw>
           </a:effectLst>
         </p:spPr>
+        <p:txBody>
+          <a:bodyPr/>
+          <a:lstStyle/>
+          <a:p>
+            <a:endParaRPr lang="en-US"/>
+          </a:p>
+        </p:txBody>
       </p:sp>
       <p:sp>
         <p:nvSpPr>
@@ -11917,11 +12064,11 @@
           <a:bodyPr wrap="square" lIns="0" tIns="0" rIns="0" bIns="0" rtlCol="0" anchor="ctr"/>
           <a:lstStyle/>
           <a:p>
-            <a:pPr indent="0" marL="0">
-              <a:buNone/>
-            </a:pPr>
-            <a:r>
-              <a:rPr lang="en-US" sz="1050" b="1" spc="150" kern="0" dirty="0">
+            <a:pPr marL="0" indent="0">
+              <a:buNone/>
+            </a:pPr>
+            <a:r>
+              <a:rPr lang="en-US" sz="1050" b="1" kern="0" spc="150" dirty="0">
                 <a:solidFill>
                   <a:srgbClr val="C07A22"/>
                 </a:solidFill>
@@ -11956,7 +12103,7 @@
           <a:bodyPr wrap="square" lIns="0" tIns="0" rIns="0" bIns="0" rtlCol="0" anchor="t"/>
           <a:lstStyle/>
           <a:p>
-            <a:pPr indent="0" marL="0">
+            <a:pPr marL="0" indent="0">
               <a:buNone/>
             </a:pPr>
             <a:r>
@@ -12000,13 +12147,20 @@
             <a:prstDash val="solid"/>
           </a:ln>
           <a:effectLst>
-            <a:outerShdw sx="100000" sy="100000" kx="0" ky="0" algn="bl" rotWithShape="0" blurRad="127000" dist="25400" dir="5400000">
+            <a:outerShdw blurRad="127000" dist="25400" dir="5400000" algn="bl" rotWithShape="0">
               <a:srgbClr val="9AAAC4">
                 <a:alpha val="30000"/>
               </a:srgbClr>
             </a:outerShdw>
           </a:effectLst>
         </p:spPr>
+        <p:txBody>
+          <a:bodyPr/>
+          <a:lstStyle/>
+          <a:p>
+            <a:endParaRPr lang="en-US"/>
+          </a:p>
+        </p:txBody>
       </p:sp>
       <p:sp>
         <p:nvSpPr>
@@ -12029,11 +12183,11 @@
           <a:bodyPr wrap="square" lIns="0" tIns="0" rIns="0" bIns="0" rtlCol="0" anchor="ctr"/>
           <a:lstStyle/>
           <a:p>
-            <a:pPr indent="0" marL="0">
-              <a:buNone/>
-            </a:pPr>
-            <a:r>
-              <a:rPr lang="en-US" sz="1050" b="1" spc="150" kern="0" dirty="0">
+            <a:pPr marL="0" indent="0">
+              <a:buNone/>
+            </a:pPr>
+            <a:r>
+              <a:rPr lang="en-US" sz="1050" b="1" kern="0" spc="150" dirty="0">
                 <a:solidFill>
                   <a:srgbClr val="C07A22"/>
                 </a:solidFill>
@@ -12068,7 +12222,7 @@
           <a:bodyPr wrap="square" lIns="0" tIns="0" rIns="0" bIns="0" rtlCol="0" anchor="t"/>
           <a:lstStyle/>
           <a:p>
-            <a:pPr indent="0" marL="0">
+            <a:pPr marL="0" indent="0">
               <a:buNone/>
             </a:pPr>
             <a:r>
@@ -12107,7 +12261,7 @@
           <a:bodyPr wrap="square" lIns="0" tIns="0" rIns="0" bIns="0" rtlCol="0" anchor="ctr"/>
           <a:lstStyle/>
           <a:p>
-            <a:pPr indent="0" marL="0">
+            <a:pPr marL="0" indent="0">
               <a:buNone/>
             </a:pPr>
             <a:r>
@@ -12151,13 +12305,20 @@
             <a:prstDash val="solid"/>
           </a:ln>
           <a:effectLst>
-            <a:outerShdw sx="100000" sy="100000" kx="0" ky="0" algn="bl" rotWithShape="0" blurRad="127000" dist="25400" dir="5400000">
+            <a:outerShdw blurRad="127000" dist="25400" dir="5400000" algn="bl" rotWithShape="0">
               <a:srgbClr val="9AAAC4">
                 <a:alpha val="30000"/>
               </a:srgbClr>
             </a:outerShdw>
           </a:effectLst>
         </p:spPr>
+        <p:txBody>
+          <a:bodyPr/>
+          <a:lstStyle/>
+          <a:p>
+            <a:endParaRPr lang="en-US"/>
+          </a:p>
+        </p:txBody>
       </p:sp>
       <p:sp>
         <p:nvSpPr>
@@ -12180,7 +12341,7 @@
           <a:bodyPr wrap="square" lIns="0" tIns="0" rIns="0" bIns="0" rtlCol="0" anchor="ctr"/>
           <a:lstStyle/>
           <a:p>
-            <a:pPr indent="0" marL="0">
+            <a:pPr marL="0" indent="0">
               <a:buNone/>
             </a:pPr>
             <a:r>
@@ -12194,9 +12355,6 @@
               </a:rPr>
               <a:t>Live  </a:t>
             </a:r>
-            <a:pPr indent="0" marL="0">
-              <a:buNone/>
-            </a:pPr>
             <a:r>
               <a:rPr lang="en-US" sz="1050" u="sng" dirty="0">
                 <a:solidFill>
@@ -12205,7 +12363,7 @@
                 <a:latin typeface="Courier New" pitchFamily="34" charset="0"/>
                 <a:ea typeface="Courier New" pitchFamily="34" charset="-122"/>
                 <a:cs typeface="Courier New" pitchFamily="34" charset="-120"/>
-                <a:hlinkClick r:id="rId1" invalidUrl="" action="" tgtFrame="" tooltip="" history="1" highlightClick="0" endSnd="0">
+                <a:hlinkClick r:id="rId3">
                   <a:extLst>
                     <a:ext uri="{A12FA001-AC4F-418D-AE19-62706E023703}">
                       <ahyp:hlinkClr xmlns:ahyp="http://schemas.microsoft.com/office/drawing/2018/hyperlinkcolor" val="tx"/>
@@ -12240,7 +12398,7 @@
           <a:bodyPr wrap="square" lIns="0" tIns="0" rIns="0" bIns="0" rtlCol="0" anchor="ctr"/>
           <a:lstStyle/>
           <a:p>
-            <a:pPr indent="0" marL="0">
+            <a:pPr marL="0" indent="0">
               <a:buNone/>
             </a:pPr>
             <a:r>
@@ -12254,9 +12412,6 @@
               </a:rPr>
               <a:t>Code  </a:t>
             </a:r>
-            <a:pPr indent="0" marL="0">
-              <a:buNone/>
-            </a:pPr>
             <a:r>
               <a:rPr lang="en-US" sz="1050" u="sng" dirty="0">
                 <a:solidFill>
@@ -12265,7 +12420,7 @@
                 <a:latin typeface="Courier New" pitchFamily="34" charset="0"/>
                 <a:ea typeface="Courier New" pitchFamily="34" charset="-122"/>
                 <a:cs typeface="Courier New" pitchFamily="34" charset="-120"/>
-                <a:hlinkClick r:id="rId2" invalidUrl="" action="" tgtFrame="" tooltip="" history="1" highlightClick="0" endSnd="0">
+                <a:hlinkClick r:id="rId4">
                   <a:extLst>
                     <a:ext uri="{A12FA001-AC4F-418D-AE19-62706E023703}">
                       <ahyp:hlinkClr xmlns:ahyp="http://schemas.microsoft.com/office/drawing/2018/hyperlinkcolor" val="tx"/>
@@ -12328,6 +12483,13 @@
             <a:prstDash val="solid"/>
           </a:ln>
         </p:spPr>
+        <p:txBody>
+          <a:bodyPr/>
+          <a:lstStyle/>
+          <a:p>
+            <a:endParaRPr lang="en-US"/>
+          </a:p>
+        </p:txBody>
       </p:sp>
       <p:sp>
         <p:nvSpPr>
@@ -12350,7 +12512,7 @@
           <a:bodyPr wrap="square" lIns="0" tIns="0" rIns="0" bIns="0" rtlCol="0" anchor="ctr"/>
           <a:lstStyle/>
           <a:p>
-            <a:pPr algn="ctr" indent="0" marL="0">
+            <a:pPr marL="0" indent="0" algn="ctr">
               <a:buNone/>
             </a:pPr>
             <a:r>
@@ -12389,7 +12551,7 @@
           <a:bodyPr wrap="square" lIns="0" tIns="0" rIns="0" bIns="0" rtlCol="0" anchor="ctr"/>
           <a:lstStyle/>
           <a:p>
-            <a:pPr indent="0" marL="0">
+            <a:pPr marL="0" indent="0">
               <a:buNone/>
             </a:pPr>
             <a:r>
@@ -12428,7 +12590,7 @@
           <a:bodyPr wrap="square" lIns="0" tIns="0" rIns="0" bIns="0" rtlCol="0" anchor="ctr"/>
           <a:lstStyle/>
           <a:p>
-            <a:pPr indent="0" marL="0">
+            <a:pPr marL="0" indent="0">
               <a:buNone/>
             </a:pPr>
             <a:r>
@@ -12472,13 +12634,20 @@
             <a:prstDash val="solid"/>
           </a:ln>
           <a:effectLst>
-            <a:outerShdw sx="100000" sy="100000" kx="0" ky="0" algn="bl" rotWithShape="0" blurRad="127000" dist="25400" dir="5400000">
+            <a:outerShdw blurRad="127000" dist="25400" dir="5400000" algn="bl" rotWithShape="0">
               <a:srgbClr val="9AAAC4">
                 <a:alpha val="30000"/>
               </a:srgbClr>
             </a:outerShdw>
           </a:effectLst>
         </p:spPr>
+        <p:txBody>
+          <a:bodyPr/>
+          <a:lstStyle/>
+          <a:p>
+            <a:endParaRPr lang="en-US"/>
+          </a:p>
+        </p:txBody>
       </p:sp>
       <p:sp>
         <p:nvSpPr>
@@ -12501,11 +12670,11 @@
           <a:bodyPr wrap="square" lIns="0" tIns="0" rIns="0" bIns="0" rtlCol="0" anchor="ctr"/>
           <a:lstStyle/>
           <a:p>
-            <a:pPr indent="0" marL="0">
-              <a:buNone/>
-            </a:pPr>
-            <a:r>
-              <a:rPr lang="en-US" sz="1050" b="1" spc="150" kern="0" dirty="0">
+            <a:pPr marL="0" indent="0">
+              <a:buNone/>
+            </a:pPr>
+            <a:r>
+              <a:rPr lang="en-US" sz="1050" b="1" kern="0" spc="150" dirty="0">
                 <a:solidFill>
                   <a:srgbClr val="C07A22"/>
                 </a:solidFill>
@@ -12540,7 +12709,7 @@
           <a:bodyPr wrap="square" lIns="0" tIns="0" rIns="0" bIns="0" rtlCol="0" anchor="t"/>
           <a:lstStyle/>
           <a:p>
-            <a:pPr indent="0" marL="0">
+            <a:pPr marL="0" indent="0">
               <a:buNone/>
             </a:pPr>
             <a:r>
@@ -12584,13 +12753,20 @@
             <a:prstDash val="solid"/>
           </a:ln>
           <a:effectLst>
-            <a:outerShdw sx="100000" sy="100000" kx="0" ky="0" algn="bl" rotWithShape="0" blurRad="127000" dist="25400" dir="5400000">
+            <a:outerShdw blurRad="127000" dist="25400" dir="5400000" algn="bl" rotWithShape="0">
               <a:srgbClr val="9AAAC4">
                 <a:alpha val="30000"/>
               </a:srgbClr>
             </a:outerShdw>
           </a:effectLst>
         </p:spPr>
+        <p:txBody>
+          <a:bodyPr/>
+          <a:lstStyle/>
+          <a:p>
+            <a:endParaRPr lang="en-US"/>
+          </a:p>
+        </p:txBody>
       </p:sp>
       <p:sp>
         <p:nvSpPr>
@@ -12613,11 +12789,11 @@
           <a:bodyPr wrap="square" lIns="0" tIns="0" rIns="0" bIns="0" rtlCol="0" anchor="ctr"/>
           <a:lstStyle/>
           <a:p>
-            <a:pPr indent="0" marL="0">
-              <a:buNone/>
-            </a:pPr>
-            <a:r>
-              <a:rPr lang="en-US" sz="1050" b="1" spc="150" kern="0" dirty="0">
+            <a:pPr marL="0" indent="0">
+              <a:buNone/>
+            </a:pPr>
+            <a:r>
+              <a:rPr lang="en-US" sz="1050" b="1" kern="0" spc="150" dirty="0">
                 <a:solidFill>
                   <a:srgbClr val="C07A22"/>
                 </a:solidFill>
@@ -12652,7 +12828,7 @@
           <a:bodyPr wrap="square" lIns="0" tIns="0" rIns="0" bIns="0" rtlCol="0" anchor="t"/>
           <a:lstStyle/>
           <a:p>
-            <a:pPr indent="0" marL="0">
+            <a:pPr marL="0" indent="0">
               <a:buNone/>
             </a:pPr>
             <a:r>
@@ -12696,13 +12872,20 @@
             <a:prstDash val="solid"/>
           </a:ln>
           <a:effectLst>
-            <a:outerShdw sx="100000" sy="100000" kx="0" ky="0" algn="bl" rotWithShape="0" blurRad="127000" dist="25400" dir="5400000">
+            <a:outerShdw blurRad="127000" dist="25400" dir="5400000" algn="bl" rotWithShape="0">
               <a:srgbClr val="9AAAC4">
                 <a:alpha val="30000"/>
               </a:srgbClr>
             </a:outerShdw>
           </a:effectLst>
         </p:spPr>
+        <p:txBody>
+          <a:bodyPr/>
+          <a:lstStyle/>
+          <a:p>
+            <a:endParaRPr lang="en-US"/>
+          </a:p>
+        </p:txBody>
       </p:sp>
       <p:sp>
         <p:nvSpPr>
@@ -12725,11 +12908,11 @@
           <a:bodyPr wrap="square" lIns="0" tIns="0" rIns="0" bIns="0" rtlCol="0" anchor="ctr"/>
           <a:lstStyle/>
           <a:p>
-            <a:pPr indent="0" marL="0">
-              <a:buNone/>
-            </a:pPr>
-            <a:r>
-              <a:rPr lang="en-US" sz="1050" b="1" spc="150" kern="0" dirty="0">
+            <a:pPr marL="0" indent="0">
+              <a:buNone/>
+            </a:pPr>
+            <a:r>
+              <a:rPr lang="en-US" sz="1050" b="1" kern="0" spc="150" dirty="0">
                 <a:solidFill>
                   <a:srgbClr val="C07A22"/>
                 </a:solidFill>
@@ -12764,7 +12947,7 @@
           <a:bodyPr wrap="square" lIns="0" tIns="0" rIns="0" bIns="0" rtlCol="0" anchor="t"/>
           <a:lstStyle/>
           <a:p>
-            <a:pPr indent="0" marL="0">
+            <a:pPr marL="0" indent="0">
               <a:buNone/>
             </a:pPr>
             <a:r>
@@ -12803,7 +12986,7 @@
           <a:bodyPr wrap="square" lIns="0" tIns="0" rIns="0" bIns="0" rtlCol="0" anchor="ctr"/>
           <a:lstStyle/>
           <a:p>
-            <a:pPr indent="0" marL="0">
+            <a:pPr marL="0" indent="0">
               <a:buNone/>
             </a:pPr>
             <a:r>
@@ -12847,13 +13030,20 @@
             <a:prstDash val="solid"/>
           </a:ln>
           <a:effectLst>
-            <a:outerShdw sx="100000" sy="100000" kx="0" ky="0" algn="bl" rotWithShape="0" blurRad="127000" dist="25400" dir="5400000">
+            <a:outerShdw blurRad="127000" dist="25400" dir="5400000" algn="bl" rotWithShape="0">
               <a:srgbClr val="9AAAC4">
                 <a:alpha val="30000"/>
               </a:srgbClr>
             </a:outerShdw>
           </a:effectLst>
         </p:spPr>
+        <p:txBody>
+          <a:bodyPr/>
+          <a:lstStyle/>
+          <a:p>
+            <a:endParaRPr lang="en-US"/>
+          </a:p>
+        </p:txBody>
       </p:sp>
       <p:sp>
         <p:nvSpPr>
@@ -12876,7 +13066,7 @@
           <a:bodyPr wrap="square" lIns="0" tIns="0" rIns="0" bIns="0" rtlCol="0" anchor="ctr"/>
           <a:lstStyle/>
           <a:p>
-            <a:pPr indent="0" marL="0">
+            <a:pPr marL="0" indent="0">
               <a:buNone/>
             </a:pPr>
             <a:r>
@@ -12890,9 +13080,6 @@
               </a:rPr>
               <a:t>Live  </a:t>
             </a:r>
-            <a:pPr indent="0" marL="0">
-              <a:buNone/>
-            </a:pPr>
             <a:r>
               <a:rPr lang="en-US" sz="1050" u="sng" dirty="0">
                 <a:solidFill>
@@ -12901,7 +13088,7 @@
                 <a:latin typeface="Courier New" pitchFamily="34" charset="0"/>
                 <a:ea typeface="Courier New" pitchFamily="34" charset="-122"/>
                 <a:cs typeface="Courier New" pitchFamily="34" charset="-120"/>
-                <a:hlinkClick r:id="rId1" invalidUrl="" action="" tgtFrame="" tooltip="" history="1" highlightClick="0" endSnd="0">
+                <a:hlinkClick r:id="rId3">
                   <a:extLst>
                     <a:ext uri="{A12FA001-AC4F-418D-AE19-62706E023703}">
                       <ahyp:hlinkClr xmlns:ahyp="http://schemas.microsoft.com/office/drawing/2018/hyperlinkcolor" val="tx"/>
@@ -12936,7 +13123,7 @@
           <a:bodyPr wrap="square" lIns="0" tIns="0" rIns="0" bIns="0" rtlCol="0" anchor="ctr"/>
           <a:lstStyle/>
           <a:p>
-            <a:pPr indent="0" marL="0">
+            <a:pPr marL="0" indent="0">
               <a:buNone/>
             </a:pPr>
             <a:r>
@@ -12950,9 +13137,6 @@
               </a:rPr>
               <a:t>Code  </a:t>
             </a:r>
-            <a:pPr indent="0" marL="0">
-              <a:buNone/>
-            </a:pPr>
             <a:r>
               <a:rPr lang="en-US" sz="1050" u="sng" dirty="0">
                 <a:solidFill>
@@ -12961,7 +13145,7 @@
                 <a:latin typeface="Courier New" pitchFamily="34" charset="0"/>
                 <a:ea typeface="Courier New" pitchFamily="34" charset="-122"/>
                 <a:cs typeface="Courier New" pitchFamily="34" charset="-120"/>
-                <a:hlinkClick r:id="rId2" invalidUrl="" action="" tgtFrame="" tooltip="" history="1" highlightClick="0" endSnd="0">
+                <a:hlinkClick r:id="rId4">
                   <a:extLst>
                     <a:ext uri="{A12FA001-AC4F-418D-AE19-62706E023703}">
                       <ahyp:hlinkClr xmlns:ahyp="http://schemas.microsoft.com/office/drawing/2018/hyperlinkcolor" val="tx"/>
@@ -13024,6 +13208,13 @@
             <a:prstDash val="solid"/>
           </a:ln>
         </p:spPr>
+        <p:txBody>
+          <a:bodyPr/>
+          <a:lstStyle/>
+          <a:p>
+            <a:endParaRPr lang="en-US"/>
+          </a:p>
+        </p:txBody>
       </p:sp>
       <p:sp>
         <p:nvSpPr>
@@ -13046,7 +13237,7 @@
           <a:bodyPr wrap="square" lIns="0" tIns="0" rIns="0" bIns="0" rtlCol="0" anchor="ctr"/>
           <a:lstStyle/>
           <a:p>
-            <a:pPr algn="ctr" indent="0" marL="0">
+            <a:pPr marL="0" indent="0" algn="ctr">
               <a:buNone/>
             </a:pPr>
             <a:r>
@@ -13085,7 +13276,7 @@
           <a:bodyPr wrap="square" lIns="0" tIns="0" rIns="0" bIns="0" rtlCol="0" anchor="ctr"/>
           <a:lstStyle/>
           <a:p>
-            <a:pPr indent="0" marL="0">
+            <a:pPr marL="0" indent="0">
               <a:buNone/>
             </a:pPr>
             <a:r>
@@ -13124,7 +13315,7 @@
           <a:bodyPr wrap="square" lIns="0" tIns="0" rIns="0" bIns="0" rtlCol="0" anchor="ctr"/>
           <a:lstStyle/>
           <a:p>
-            <a:pPr indent="0" marL="0">
+            <a:pPr marL="0" indent="0">
               <a:buNone/>
             </a:pPr>
             <a:r>
@@ -13168,13 +13359,20 @@
             <a:prstDash val="solid"/>
           </a:ln>
           <a:effectLst>
-            <a:outerShdw sx="100000" sy="100000" kx="0" ky="0" algn="bl" rotWithShape="0" blurRad="127000" dist="25400" dir="5400000">
+            <a:outerShdw blurRad="127000" dist="25400" dir="5400000" algn="bl" rotWithShape="0">
               <a:srgbClr val="9AAAC4">
                 <a:alpha val="30000"/>
               </a:srgbClr>
             </a:outerShdw>
           </a:effectLst>
         </p:spPr>
+        <p:txBody>
+          <a:bodyPr/>
+          <a:lstStyle/>
+          <a:p>
+            <a:endParaRPr lang="en-US"/>
+          </a:p>
+        </p:txBody>
       </p:sp>
       <p:sp>
         <p:nvSpPr>
@@ -13197,11 +13395,11 @@
           <a:bodyPr wrap="square" lIns="0" tIns="0" rIns="0" bIns="0" rtlCol="0" anchor="ctr"/>
           <a:lstStyle/>
           <a:p>
-            <a:pPr indent="0" marL="0">
-              <a:buNone/>
-            </a:pPr>
-            <a:r>
-              <a:rPr lang="en-US" sz="1050" b="1" spc="150" kern="0" dirty="0">
+            <a:pPr marL="0" indent="0">
+              <a:buNone/>
+            </a:pPr>
+            <a:r>
+              <a:rPr lang="en-US" sz="1050" b="1" kern="0" spc="150" dirty="0">
                 <a:solidFill>
                   <a:srgbClr val="C07A22"/>
                 </a:solidFill>
@@ -13236,7 +13434,7 @@
           <a:bodyPr wrap="square" lIns="0" tIns="0" rIns="0" bIns="0" rtlCol="0" anchor="t"/>
           <a:lstStyle/>
           <a:p>
-            <a:pPr indent="0" marL="0">
+            <a:pPr marL="0" indent="0">
               <a:buNone/>
             </a:pPr>
             <a:r>
@@ -13280,13 +13478,20 @@
             <a:prstDash val="solid"/>
           </a:ln>
           <a:effectLst>
-            <a:outerShdw sx="100000" sy="100000" kx="0" ky="0" algn="bl" rotWithShape="0" blurRad="127000" dist="25400" dir="5400000">
+            <a:outerShdw blurRad="127000" dist="25400" dir="5400000" algn="bl" rotWithShape="0">
               <a:srgbClr val="9AAAC4">
                 <a:alpha val="30000"/>
               </a:srgbClr>
             </a:outerShdw>
           </a:effectLst>
         </p:spPr>
+        <p:txBody>
+          <a:bodyPr/>
+          <a:lstStyle/>
+          <a:p>
+            <a:endParaRPr lang="en-US"/>
+          </a:p>
+        </p:txBody>
       </p:sp>
       <p:sp>
         <p:nvSpPr>
@@ -13309,11 +13514,11 @@
           <a:bodyPr wrap="square" lIns="0" tIns="0" rIns="0" bIns="0" rtlCol="0" anchor="ctr"/>
           <a:lstStyle/>
           <a:p>
-            <a:pPr indent="0" marL="0">
-              <a:buNone/>
-            </a:pPr>
-            <a:r>
-              <a:rPr lang="en-US" sz="1050" b="1" spc="150" kern="0" dirty="0">
+            <a:pPr marL="0" indent="0">
+              <a:buNone/>
+            </a:pPr>
+            <a:r>
+              <a:rPr lang="en-US" sz="1050" b="1" kern="0" spc="150" dirty="0">
                 <a:solidFill>
                   <a:srgbClr val="C07A22"/>
                 </a:solidFill>
@@ -13348,7 +13553,7 @@
           <a:bodyPr wrap="square" lIns="0" tIns="0" rIns="0" bIns="0" rtlCol="0" anchor="t"/>
           <a:lstStyle/>
           <a:p>
-            <a:pPr indent="0" marL="0">
+            <a:pPr marL="0" indent="0">
               <a:buNone/>
             </a:pPr>
             <a:r>
@@ -13392,13 +13597,20 @@
             <a:prstDash val="solid"/>
           </a:ln>
           <a:effectLst>
-            <a:outerShdw sx="100000" sy="100000" kx="0" ky="0" algn="bl" rotWithShape="0" blurRad="127000" dist="25400" dir="5400000">
+            <a:outerShdw blurRad="127000" dist="25400" dir="5400000" algn="bl" rotWithShape="0">
               <a:srgbClr val="9AAAC4">
                 <a:alpha val="30000"/>
               </a:srgbClr>
             </a:outerShdw>
           </a:effectLst>
         </p:spPr>
+        <p:txBody>
+          <a:bodyPr/>
+          <a:lstStyle/>
+          <a:p>
+            <a:endParaRPr lang="en-US"/>
+          </a:p>
+        </p:txBody>
       </p:sp>
       <p:sp>
         <p:nvSpPr>
@@ -13421,11 +13633,11 @@
           <a:bodyPr wrap="square" lIns="0" tIns="0" rIns="0" bIns="0" rtlCol="0" anchor="ctr"/>
           <a:lstStyle/>
           <a:p>
-            <a:pPr indent="0" marL="0">
-              <a:buNone/>
-            </a:pPr>
-            <a:r>
-              <a:rPr lang="en-US" sz="1050" b="1" spc="150" kern="0" dirty="0">
+            <a:pPr marL="0" indent="0">
+              <a:buNone/>
+            </a:pPr>
+            <a:r>
+              <a:rPr lang="en-US" sz="1050" b="1" kern="0" spc="150" dirty="0">
                 <a:solidFill>
                   <a:srgbClr val="C07A22"/>
                 </a:solidFill>
@@ -13460,7 +13672,7 @@
           <a:bodyPr wrap="square" lIns="0" tIns="0" rIns="0" bIns="0" rtlCol="0" anchor="t"/>
           <a:lstStyle/>
           <a:p>
-            <a:pPr indent="0" marL="0">
+            <a:pPr marL="0" indent="0">
               <a:buNone/>
             </a:pPr>
             <a:r>
@@ -13499,7 +13711,7 @@
           <a:bodyPr wrap="square" lIns="0" tIns="0" rIns="0" bIns="0" rtlCol="0" anchor="ctr"/>
           <a:lstStyle/>
           <a:p>
-            <a:pPr indent="0" marL="0">
+            <a:pPr marL="0" indent="0">
               <a:buNone/>
             </a:pPr>
             <a:r>
@@ -13543,13 +13755,20 @@
             <a:prstDash val="solid"/>
           </a:ln>
           <a:effectLst>
-            <a:outerShdw sx="100000" sy="100000" kx="0" ky="0" algn="bl" rotWithShape="0" blurRad="127000" dist="25400" dir="5400000">
+            <a:outerShdw blurRad="127000" dist="25400" dir="5400000" algn="bl" rotWithShape="0">
               <a:srgbClr val="9AAAC4">
                 <a:alpha val="30000"/>
               </a:srgbClr>
             </a:outerShdw>
           </a:effectLst>
         </p:spPr>
+        <p:txBody>
+          <a:bodyPr/>
+          <a:lstStyle/>
+          <a:p>
+            <a:endParaRPr lang="en-US"/>
+          </a:p>
+        </p:txBody>
       </p:sp>
       <p:sp>
         <p:nvSpPr>
@@ -13572,7 +13791,7 @@
           <a:bodyPr wrap="square" lIns="0" tIns="0" rIns="0" bIns="0" rtlCol="0" anchor="ctr"/>
           <a:lstStyle/>
           <a:p>
-            <a:pPr indent="0" marL="0">
+            <a:pPr marL="0" indent="0">
               <a:buNone/>
             </a:pPr>
             <a:r>
@@ -13586,9 +13805,6 @@
               </a:rPr>
               <a:t>Code  </a:t>
             </a:r>
-            <a:pPr indent="0" marL="0">
-              <a:buNone/>
-            </a:pPr>
             <a:r>
               <a:rPr lang="en-US" sz="1050" u="sng" dirty="0">
                 <a:solidFill>
@@ -13597,7 +13813,7 @@
                 <a:latin typeface="Courier New" pitchFamily="34" charset="0"/>
                 <a:ea typeface="Courier New" pitchFamily="34" charset="-122"/>
                 <a:cs typeface="Courier New" pitchFamily="34" charset="-120"/>
-                <a:hlinkClick r:id="rId1" invalidUrl="" action="" tgtFrame="" tooltip="" history="1" highlightClick="0" endSnd="0">
+                <a:hlinkClick r:id="rId3">
                   <a:extLst>
                     <a:ext uri="{A12FA001-AC4F-418D-AE19-62706E023703}">
                       <ahyp:hlinkClr xmlns:ahyp="http://schemas.microsoft.com/office/drawing/2018/hyperlinkcolor" val="tx"/>
@@ -13632,7 +13848,7 @@
           <a:bodyPr wrap="square" lIns="0" tIns="0" rIns="0" bIns="0" rtlCol="0" anchor="ctr"/>
           <a:lstStyle/>
           <a:p>
-            <a:pPr indent="0" marL="0">
+            <a:pPr marL="0" indent="0">
               <a:buNone/>
             </a:pPr>
             <a:r>
@@ -13951,4 +14167,319 @@
     </a:ext>
   </a:extLst>
 </a:theme>
+</file>
+
+<file path=ppt/theme/theme2.xml><?xml version="1.0" encoding="utf-8"?>
+<a:theme xmlns:a="http://schemas.openxmlformats.org/drawingml/2006/main" name="Office Theme">
+  <a:themeElements>
+    <a:clrScheme name="Office">
+      <a:dk1>
+        <a:sysClr val="windowText" lastClr="000000"/>
+      </a:dk1>
+      <a:lt1>
+        <a:sysClr val="window" lastClr="FFFFFF"/>
+      </a:lt1>
+      <a:dk2>
+        <a:srgbClr val="0E2841"/>
+      </a:dk2>
+      <a:lt2>
+        <a:srgbClr val="E8E8E8"/>
+      </a:lt2>
+      <a:accent1>
+        <a:srgbClr val="156082"/>
+      </a:accent1>
+      <a:accent2>
+        <a:srgbClr val="E97132"/>
+      </a:accent2>
+      <a:accent3>
+        <a:srgbClr val="196B24"/>
+      </a:accent3>
+      <a:accent4>
+        <a:srgbClr val="0F9ED5"/>
+      </a:accent4>
+      <a:accent5>
+        <a:srgbClr val="A02B93"/>
+      </a:accent5>
+      <a:accent6>
+        <a:srgbClr val="4EA72E"/>
+      </a:accent6>
+      <a:hlink>
+        <a:srgbClr val="467886"/>
+      </a:hlink>
+      <a:folHlink>
+        <a:srgbClr val="96607D"/>
+      </a:folHlink>
+    </a:clrScheme>
+    <a:fontScheme name="Office">
+      <a:majorFont>
+        <a:latin typeface="Aptos Display" panose="02110004020202020204"/>
+        <a:ea typeface=""/>
+        <a:cs typeface=""/>
+        <a:font script="Jpan" typeface="游ゴシック Light"/>
+        <a:font script="Hang" typeface="맑은 고딕"/>
+        <a:font script="Hans" typeface="等线 Light"/>
+        <a:font script="Hant" typeface="新細明體"/>
+        <a:font script="Arab" typeface="Times New Roman"/>
+        <a:font script="Hebr" typeface="Times New Roman"/>
+        <a:font script="Thai" typeface="Angsana New"/>
+        <a:font script="Ethi" typeface="Nyala"/>
+        <a:font script="Beng" typeface="Vrinda"/>
+        <a:font script="Gujr" typeface="Shruti"/>
+        <a:font script="Khmr" typeface="MoolBoran"/>
+        <a:font script="Knda" typeface="Tunga"/>
+        <a:font script="Guru" typeface="Raavi"/>
+        <a:font script="Cans" typeface="Euphemia"/>
+        <a:font script="Cher" typeface="Plantagenet Cherokee"/>
+        <a:font script="Yiii" typeface="Microsoft Yi Baiti"/>
+        <a:font script="Tibt" typeface="Microsoft Himalaya"/>
+        <a:font script="Thaa" typeface="MV Boli"/>
+        <a:font script="Deva" typeface="Mangal"/>
+        <a:font script="Telu" typeface="Gautami"/>
+        <a:font script="Taml" typeface="Latha"/>
+        <a:font script="Syrc" typeface="Estrangelo Edessa"/>
+        <a:font script="Orya" typeface="Kalinga"/>
+        <a:font script="Mlym" typeface="Kartika"/>
+        <a:font script="Laoo" typeface="DokChampa"/>
+        <a:font script="Sinh" typeface="Iskoola Pota"/>
+        <a:font script="Mong" typeface="Mongolian Baiti"/>
+        <a:font script="Viet" typeface="Times New Roman"/>
+        <a:font script="Uigh" typeface="Microsoft Uighur"/>
+        <a:font script="Geor" typeface="Sylfaen"/>
+        <a:font script="Armn" typeface="Arial"/>
+        <a:font script="Bugi" typeface="Leelawadee UI"/>
+        <a:font script="Bopo" typeface="Microsoft JhengHei"/>
+        <a:font script="Java" typeface="Javanese Text"/>
+        <a:font script="Lisu" typeface="Segoe UI"/>
+        <a:font script="Mymr" typeface="Myanmar Text"/>
+        <a:font script="Nkoo" typeface="Ebrima"/>
+        <a:font script="Olck" typeface="Nirmala UI"/>
+        <a:font script="Osma" typeface="Ebrima"/>
+        <a:font script="Phag" typeface="Phagspa"/>
+        <a:font script="Syrn" typeface="Estrangelo Edessa"/>
+        <a:font script="Syrj" typeface="Estrangelo Edessa"/>
+        <a:font script="Syre" typeface="Estrangelo Edessa"/>
+        <a:font script="Sora" typeface="Nirmala UI"/>
+        <a:font script="Tale" typeface="Microsoft Tai Le"/>
+        <a:font script="Talu" typeface="Microsoft New Tai Lue"/>
+        <a:font script="Tfng" typeface="Ebrima"/>
+      </a:majorFont>
+      <a:minorFont>
+        <a:latin typeface="Aptos" panose="02110004020202020204"/>
+        <a:ea typeface=""/>
+        <a:cs typeface=""/>
+        <a:font script="Jpan" typeface="游ゴシック"/>
+        <a:font script="Hang" typeface="맑은 고딕"/>
+        <a:font script="Hans" typeface="等线"/>
+        <a:font script="Hant" typeface="新細明體"/>
+        <a:font script="Arab" typeface="Arial"/>
+        <a:font script="Hebr" typeface="Arial"/>
+        <a:font script="Thai" typeface="Cordia New"/>
+        <a:font script="Ethi" typeface="Nyala"/>
+        <a:font script="Beng" typeface="Vrinda"/>
+        <a:font script="Gujr" typeface="Shruti"/>
+        <a:font script="Khmr" typeface="DaunPenh"/>
+        <a:font script="Knda" typeface="Tunga"/>
+        <a:font script="Guru" typeface="Raavi"/>
+        <a:font script="Cans" typeface="Euphemia"/>
+        <a:font script="Cher" typeface="Plantagenet Cherokee"/>
+        <a:font script="Yiii" typeface="Microsoft Yi Baiti"/>
+        <a:font script="Tibt" typeface="Microsoft Himalaya"/>
+        <a:font script="Thaa" typeface="MV Boli"/>
+        <a:font script="Deva" typeface="Mangal"/>
+        <a:font script="Telu" typeface="Gautami"/>
+        <a:font script="Taml" typeface="Latha"/>
+        <a:font script="Syrc" typeface="Estrangelo Edessa"/>
+        <a:font script="Orya" typeface="Kalinga"/>
+        <a:font script="Mlym" typeface="Kartika"/>
+        <a:font script="Laoo" typeface="DokChampa"/>
+        <a:font script="Sinh" typeface="Iskoola Pota"/>
+        <a:font script="Mong" typeface="Mongolian Baiti"/>
+        <a:font script="Viet" typeface="Arial"/>
+        <a:font script="Uigh" typeface="Microsoft Uighur"/>
+        <a:font script="Geor" typeface="Sylfaen"/>
+        <a:font script="Armn" typeface="Arial"/>
+        <a:font script="Bugi" typeface="Leelawadee UI"/>
+        <a:font script="Bopo" typeface="Microsoft JhengHei"/>
+        <a:font script="Java" typeface="Javanese Text"/>
+        <a:font script="Lisu" typeface="Segoe UI"/>
+        <a:font script="Mymr" typeface="Myanmar Text"/>
+        <a:font script="Nkoo" typeface="Ebrima"/>
+        <a:font script="Olck" typeface="Nirmala UI"/>
+        <a:font script="Osma" typeface="Ebrima"/>
+        <a:font script="Phag" typeface="Phagspa"/>
+        <a:font script="Syrn" typeface="Estrangelo Edessa"/>
+        <a:font script="Syrj" typeface="Estrangelo Edessa"/>
+        <a:font script="Syre" typeface="Estrangelo Edessa"/>
+        <a:font script="Sora" typeface="Nirmala UI"/>
+        <a:font script="Tale" typeface="Microsoft Tai Le"/>
+        <a:font script="Talu" typeface="Microsoft New Tai Lue"/>
+        <a:font script="Tfng" typeface="Ebrima"/>
+      </a:minorFont>
+    </a:fontScheme>
+    <a:fmtScheme name="Office">
+      <a:fillStyleLst>
+        <a:solidFill>
+          <a:schemeClr val="phClr"/>
+        </a:solidFill>
+        <a:gradFill rotWithShape="1">
+          <a:gsLst>
+            <a:gs pos="0">
+              <a:schemeClr val="phClr">
+                <a:lumMod val="110000"/>
+                <a:satMod val="105000"/>
+                <a:tint val="67000"/>
+              </a:schemeClr>
+            </a:gs>
+            <a:gs pos="50000">
+              <a:schemeClr val="phClr">
+                <a:lumMod val="105000"/>
+                <a:satMod val="103000"/>
+                <a:tint val="73000"/>
+              </a:schemeClr>
+            </a:gs>
+            <a:gs pos="100000">
+              <a:schemeClr val="phClr">
+                <a:lumMod val="105000"/>
+                <a:satMod val="109000"/>
+                <a:tint val="81000"/>
+              </a:schemeClr>
+            </a:gs>
+          </a:gsLst>
+          <a:lin ang="5400000" scaled="0"/>
+        </a:gradFill>
+        <a:gradFill rotWithShape="1">
+          <a:gsLst>
+            <a:gs pos="0">
+              <a:schemeClr val="phClr">
+                <a:satMod val="103000"/>
+                <a:lumMod val="102000"/>
+                <a:tint val="94000"/>
+              </a:schemeClr>
+            </a:gs>
+            <a:gs pos="50000">
+              <a:schemeClr val="phClr">
+                <a:satMod val="110000"/>
+                <a:lumMod val="100000"/>
+                <a:shade val="100000"/>
+              </a:schemeClr>
+            </a:gs>
+            <a:gs pos="100000">
+              <a:schemeClr val="phClr">
+                <a:lumMod val="99000"/>
+                <a:satMod val="120000"/>
+                <a:shade val="78000"/>
+              </a:schemeClr>
+            </a:gs>
+          </a:gsLst>
+          <a:lin ang="5400000" scaled="0"/>
+        </a:gradFill>
+      </a:fillStyleLst>
+      <a:lnStyleLst>
+        <a:ln w="12700" cap="flat" cmpd="sng" algn="ctr">
+          <a:solidFill>
+            <a:schemeClr val="phClr"/>
+          </a:solidFill>
+          <a:prstDash val="solid"/>
+          <a:miter lim="800000"/>
+        </a:ln>
+        <a:ln w="19050" cap="flat" cmpd="sng" algn="ctr">
+          <a:solidFill>
+            <a:schemeClr val="phClr"/>
+          </a:solidFill>
+          <a:prstDash val="solid"/>
+          <a:miter lim="800000"/>
+        </a:ln>
+        <a:ln w="25400" cap="flat" cmpd="sng" algn="ctr">
+          <a:solidFill>
+            <a:schemeClr val="phClr"/>
+          </a:solidFill>
+          <a:prstDash val="solid"/>
+          <a:miter lim="800000"/>
+        </a:ln>
+      </a:lnStyleLst>
+      <a:effectStyleLst>
+        <a:effectStyle>
+          <a:effectLst/>
+        </a:effectStyle>
+        <a:effectStyle>
+          <a:effectLst/>
+        </a:effectStyle>
+        <a:effectStyle>
+          <a:effectLst>
+            <a:outerShdw blurRad="57150" dist="19050" dir="5400000" algn="ctr" rotWithShape="0">
+              <a:srgbClr val="000000">
+                <a:alpha val="63000"/>
+              </a:srgbClr>
+            </a:outerShdw>
+          </a:effectLst>
+        </a:effectStyle>
+      </a:effectStyleLst>
+      <a:bgFillStyleLst>
+        <a:solidFill>
+          <a:schemeClr val="phClr"/>
+        </a:solidFill>
+        <a:solidFill>
+          <a:schemeClr val="phClr">
+            <a:tint val="95000"/>
+            <a:satMod val="170000"/>
+          </a:schemeClr>
+        </a:solidFill>
+        <a:gradFill rotWithShape="1">
+          <a:gsLst>
+            <a:gs pos="0">
+              <a:schemeClr val="phClr">
+                <a:tint val="93000"/>
+                <a:satMod val="150000"/>
+                <a:shade val="98000"/>
+                <a:lumMod val="102000"/>
+              </a:schemeClr>
+            </a:gs>
+            <a:gs pos="50000">
+              <a:schemeClr val="phClr">
+                <a:tint val="98000"/>
+                <a:satMod val="130000"/>
+                <a:shade val="90000"/>
+                <a:lumMod val="103000"/>
+              </a:schemeClr>
+            </a:gs>
+            <a:gs pos="100000">
+              <a:schemeClr val="phClr">
+                <a:shade val="63000"/>
+                <a:satMod val="120000"/>
+              </a:schemeClr>
+            </a:gs>
+          </a:gsLst>
+          <a:lin ang="5400000" scaled="0"/>
+        </a:gradFill>
+      </a:bgFillStyleLst>
+    </a:fmtScheme>
+  </a:themeElements>
+  <a:objectDefaults>
+    <a:lnDef>
+      <a:spPr/>
+      <a:bodyPr/>
+      <a:lstStyle/>
+      <a:style>
+        <a:lnRef idx="2">
+          <a:schemeClr val="accent1"/>
+        </a:lnRef>
+        <a:fillRef idx="0">
+          <a:schemeClr val="accent1"/>
+        </a:fillRef>
+        <a:effectRef idx="1">
+          <a:schemeClr val="accent1"/>
+        </a:effectRef>
+        <a:fontRef idx="minor">
+          <a:schemeClr val="tx1"/>
+        </a:fontRef>
+      </a:style>
+    </a:lnDef>
+  </a:objectDefaults>
+  <a:extraClrSchemeLst/>
+  <a:extLst>
+    <a:ext uri="{05A4C25C-085E-4340-85A3-A5531E510DB2}">
+      <thm15:themeFamily xmlns:thm15="http://schemas.microsoft.com/office/thememl/2012/main" name="Office Theme" id="{2E142A2C-CD16-42D6-873A-C26D2A0506FA}" vid="{1BDDFF52-6CD6-40A5-AB3C-68EB2F1E4D0A}"/>
+    </a:ext>
+  </a:extLst>
+</a:theme>
 </file>
</xml_diff>